<commit_message>
Slaydlar: boyroq matn (asosiy fikr + izoh kartochkalari)
Co-Authored-By: Claude Opus 5.5 <noreply@anthropic.com>
</commit_message>
<xml_diff>
--- a/slaydlar/M1.pptx
+++ b/slaydlar/M1.pptx
@@ -22,6 +22,7 @@
     <p:sldId id="270" r:id="rId22"/>
     <p:sldId id="271" r:id="rId23"/>
     <p:sldId id="272" r:id="rId24"/>
+    <p:sldId id="273" r:id="rId25"/>
   </p:sldIdLst>
   <p:sldSz cx="12192000" cy="6858000" type="screen4x3"/>
   <p:notesSz cx="6858000" cy="9144000"/>
@@ -924,25 +925,55 @@
           <a:lstStyle/>
           <a:p>
             <a:r>
-              <a:t>Hardware–software co-design — tizimning apparat va dasturiy qismlarini alohida emas, balki bir vaqtning o'zida, bir-biriga moslashtirib loyihalash metodologiyasi. An'anaviy yondashuvda apparat avval tanlanadi (yoki mavjud bo'ladi), so'ng dastur unga moslashtiriladi. SI tizimlarida bu yondashuv ikki sababga ko'ra ishlamaydi: birinchidan, model arxitekturasi (qatlamlar soni, kanallar, aniqlik) o'zi loyihalash parametri bo'lib, uni apparatga qarab o'zgartirish mumkin; ikkinchidan, tezlatkichlar shunchalik ixtisoslashganki, ularga mos kelmaydigan model (masalan, Tensor Core uchun 8 ga karrali bo'lmagan kanal soni) unumdorlikni bir necha barobar yo'qotadi.</a:t>
+              <a:t>AI-enabled kompyuter tizimi — bu funksionalligining muhim qismi o'qitilgan model orqali amalga oshiriladigan tizim. Uning arxitekturasini besh qatlamli model sifatida tasavvur qilish qulay:</a:t>
             </a:r>
           </a:p>
           <a:p/>
           <a:p>
             <a:r>
-              <a:t>Co-design jarayonini to'rt o'lchovli izlanish fazosi sifatida tasavvur qilish mumkin:</a:t>
+              <a:t>Ma'lumot qabul qilish qatlami (ingestion) — sensorlar, kameralar, jurnallar, foydalanuvchi so'rovlari. Bu yerda protokollar (RTSP, MQTT, HTTP/gRPC), kodeklar (H.264/H.265) va buferlash hal qilinadi.</a:t>
             </a:r>
           </a:p>
           <a:p/>
           <a:p>
             <a:r>
-              <a:t>Co-design amaliy jihatdan iterativ jarayon. Birinchi iteratsiyada talab (kechikish, aniqlik, byudjet, energiya) qo'yiladi va nomzod model hamda nomzod apparat tanlanadi. Ikkinchi iteratsiyada model shu apparatda profillanadi — qaysi qatlamlar sekin, xotira yetarlimi, tezlatkichdan foydalanish qanday. Uchinchi iteratsiyada ikki tomon ham moslashtiriladi: model kvantlanadi yoki kichikroq variant olinadi, apparat tomonida esa paket hajmi, oqimlar soni, xotira joylashuvi sozlanadi. Bu sikl talab bajarilguncha takrorlanadi. Sze va hammualliflar [4] bu jarayonni «algoritm–apparat birgalikdagi loyihalash» deb atab, neyron tarmoqning energiya sarfi asosan hisoblashda emas, xotiraga murojaatda ekanini ko'rsatadilar: 45 nm texnologiyada DRAM dan 32 bit o'qish taxminan 640 pJ energiya talab qiladi, 32 bitli ko'paytirish esa atigi 3,7 pJ — ya'ni ma'lumotni joyida saqlab, qayta ishlatish (data reuse) har qanday hisoblash optimizatsiyasidan muhimroq.</a:t>
+              <a:t>Oldindan ishlov berish qatlami (preprocessing) — dekodlash, o'lchamini o'zgartirish, normallashtirish, tokenlashtirish. Ko'pincha e'tibordan chetda qoladi, lekin video tizimlarida dekodlash inferensdan ko'ra ko'proq resurs talab qilishi mumkin.</a:t>
             </a:r>
           </a:p>
           <a:p/>
           <a:p>
             <a:r>
-              <a:t>Co-design kontekstida ikki klassik qonun doimo yodda bo'lishi kerak. Amdal qonuni (Amdahl's law): agar dasturning p ulushi tezlashtirilsa va qolgan 1−p ulushi o'zgarmasa, umumiy tezlashuv S = 1 / ((1−p) + p/s) dan oshmaydi, bu yerda s — tezlashtirilgan qismning tezlashuvi. Video-analitikada inferens kadr vaqtining 60 % ini egallasa va uni cheksiz tezlashtirsak ham, umumiy tezlashuv 2,5 baravardan oshmaydi — dekodlash va keyingi ishlov cheklaydi. Roofline modeli esa yukning arifmetik intensivligi (FLOP / bayt) asosida u hisoblash yoki xotira bilan cheklanganini ko'rsatadi; bu model M10 da batafsil ko'riladi, lekin co-design ning har bir qadamida ishlatiladi.</a:t>
+              <a:t>Inferens qatlami — modelning o'zi va uni bajaruvchi ish vaqti muhiti (PyTorch, ONNX Runtime, TensorRT, OpenVINO). Bu qatlam tezlatkich bilan bevosita ishlaydi.</a:t>
+            </a:r>
+          </a:p>
+          <a:p/>
+          <a:p>
+            <a:r>
+              <a:t>Orkestratsiya va biznes mantiq qatlami — natijalarni birlashtirish, qoidalar, kuzatish (tracking), hodisalarni yaratish, saqlash, boshqa tizimlarga uzatish.</a:t>
+            </a:r>
+          </a:p>
+          <a:p/>
+          <a:p>
+            <a:r>
+              <a:t>Kuzatuv va boshqaruv qatlami (observability) — metrikalar (kechikish, o'tkazuvchanlik, GPU bandligi), jurnallar, model sifati monitoringi, versiya boshqaruvi.</a:t>
+            </a:r>
+          </a:p>
+          <a:p/>
+          <a:p>
+            <a:r>
+              <a:t>Qatlamlar orasidagi interfeyslar aniq belgilanishi kerak, chunki ular apparat chegaralari bilan mos tushadi: masalan, 1-2-qatlamlar CPU va video dekoder (NVDEC) da, 3-qatlam GPU da, 4-5-qatlamlar CPU da ishlashi mumkin. Ma'lumotning bu chegaralardan o'tishi — xost va qurilma xotirasi o'rtasida nusxalash — ko'pincha asosiy to'siq (bottleneck) bo'ladi. Shu sababli zamonaviy arxitekturalarda «nol nusxalash» (zero-copy) yondashuvi — dekodlangan kadrni GPU xotirasida qoldirib, to'g'ridan-to'g'ri inferensga uzatish — keng qo'llaniladi.</a:t>
+            </a:r>
+          </a:p>
+          <a:p/>
+          <a:p>
+            <a:r>
+              <a:t>Arxitekturaning yana bir o'lchovi — inferens rejimi. Onlayn (real vaqt) rejimda har bir so'rov alohida va kechikish muhim; paketli (batch) rejimda so'rovlar to'planib, o'tkazuvchanlik muhim; oqimli (streaming) rejimda uzluksiz ma'lumot oqimi qayta ishlanadi. Har rejim uchun maqbul apparat va dasturiy yechim boshqa: onlayn rejimda kichik paket (batch size 1–4) va past kechikishli tezlatkich; paketli rejimda katta paket (64–256) va yuqori o'tkazuvchanlik; oqimli rejimda esa dekodlash–inferens–kuzatish quvuri (pipeline) ning muvozanati hal qiluvchi.</a:t>
+            </a:r>
+          </a:p>
+          <a:p/>
+          <a:p>
+            <a:r>
+              <a:t>Ko'rsatkichlarni rasmiylashtiraylik. Agar tizim N ta kameradan har biri f kadr/soniya tezlikda ma'lumot olsa va model bitta kadr uchun C FLOP talab qilsa, zarur hisoblash quvvati P = N × f × C / η bo'ladi, bu yerda η — tezlatkichdan real foydalanish koeffitsiyenti (odatda 0,2–0,6). Masalan, 16 kamera, 25 kadr/s, YOLOv8s modeli (640×640 kirishda taxminan 28,6 GFLOP) va η = 0,35 uchun P ≈ 16 × 25 × 28,6 × 10⁹ / 0,35 ≈ 32,7 TFLOPS kerak bo'ladi. Bu raqam Jetson Orin Nano (taxminan 20 TFLOPS FP16 zich hisobda) uchun ko'p, lekin Jetson AGX Orin yoki bitta L4 uchun yetarli. Ana shu oddiy hisob platforma tanlashning birinchi qadamidir.</a:t>
             </a:r>
           </a:p>
         </p:txBody>
@@ -968,6 +999,94 @@
 </file>
 
 <file path=ppt/notesSlides/notesSlide6.xml><?xml version="1.0" encoding="utf-8"?>
+<p:notes xmlns:a="http://schemas.openxmlformats.org/drawingml/2006/main" xmlns:p="http://schemas.openxmlformats.org/presentationml/2006/main" xmlns:r="http://schemas.openxmlformats.org/officeDocument/2006/relationships">
+  <p:cSld>
+    <p:spTree>
+      <p:nvGrpSpPr>
+        <p:cNvPr id="1" name=""/>
+        <p:cNvGrpSpPr/>
+        <p:nvPr/>
+      </p:nvGrpSpPr>
+      <p:grpSpPr>
+        <a:xfrm>
+          <a:off x="0" y="0"/>
+          <a:ext cx="0" cy="0"/>
+          <a:chOff x="0" y="0"/>
+          <a:chExt cx="0" cy="0"/>
+        </a:xfrm>
+      </p:grpSpPr>
+      <p:sp>
+        <p:nvSpPr>
+          <p:cNvPr id="2" name="Slide Image Placeholder 1"/>
+          <p:cNvSpPr>
+            <a:spLocks noGrp="1"/>
+          </p:cNvSpPr>
+          <p:nvPr>
+            <p:ph type="sldImg" idx="2"/>
+          </p:nvPr>
+        </p:nvSpPr>
+        <p:spPr/>
+      </p:sp>
+      <p:sp>
+        <p:nvSpPr>
+          <p:cNvPr id="3" name="Notes Placeholder 2"/>
+          <p:cNvSpPr>
+            <a:spLocks noGrp="1"/>
+          </p:cNvSpPr>
+          <p:nvPr>
+            <p:ph type="body" idx="3" sz="quarter"/>
+          </p:nvPr>
+        </p:nvSpPr>
+        <p:spPr/>
+        <p:txBody>
+          <a:bodyPr/>
+          <a:lstStyle/>
+          <a:p>
+            <a:r>
+              <a:t>Hardware–software co-design — tizimning apparat va dasturiy qismlarini alohida emas, balki bir vaqtning o'zida, bir-biriga moslashtirib loyihalash metodologiyasi. An'anaviy yondashuvda apparat avval tanlanadi (yoki mavjud bo'ladi), so'ng dastur unga moslashtiriladi. SI tizimlarida bu yondashuv ikki sababga ko'ra ishlamaydi: birinchidan, model arxitekturasi (qatlamlar soni, kanallar, aniqlik) o'zi loyihalash parametri bo'lib, uni apparatga qarab o'zgartirish mumkin; ikkinchidan, tezlatkichlar shunchalik ixtisoslashganki, ularga mos kelmaydigan model (masalan, Tensor Core uchun 8 ga karrali bo'lmagan kanal soni) unumdorlikni bir necha barobar yo'qotadi.</a:t>
+            </a:r>
+          </a:p>
+          <a:p/>
+          <a:p>
+            <a:r>
+              <a:t>Co-design jarayonini to'rt o'lchovli izlanish fazosi sifatida tasavvur qilish mumkin:</a:t>
+            </a:r>
+          </a:p>
+          <a:p/>
+          <a:p>
+            <a:r>
+              <a:t>Co-design amaliy jihatdan iterativ jarayon. Birinchi iteratsiyada talab (kechikish, aniqlik, byudjet, energiya) qo'yiladi va nomzod model hamda nomzod apparat tanlanadi. Ikkinchi iteratsiyada model shu apparatda profillanadi — qaysi qatlamlar sekin, xotira yetarlimi, tezlatkichdan foydalanish qanday. Uchinchi iteratsiyada ikki tomon ham moslashtiriladi: model kvantlanadi yoki kichikroq variant olinadi, apparat tomonida esa paket hajmi, oqimlar soni, xotira joylashuvi sozlanadi. Bu sikl talab bajarilguncha takrorlanadi. Sze va hammualliflar [4] bu jarayonni «algoritm–apparat birgalikdagi loyihalash» deb atab, neyron tarmoqning energiya sarfi asosan hisoblashda emas, xotiraga murojaatda ekanini ko'rsatadilar: 45 nm texnologiyada DRAM dan 32 bit o'qish taxminan 640 pJ energiya talab qiladi, 32 bitli ko'paytirish esa atigi 3,7 pJ — ya'ni ma'lumotni joyida saqlab, qayta ishlatish (data reuse) har qanday hisoblash optimizatsiyasidan muhimroq.</a:t>
+            </a:r>
+          </a:p>
+          <a:p/>
+          <a:p>
+            <a:r>
+              <a:t>Co-design kontekstida ikki klassik qonun doimo yodda bo'lishi kerak. Amdal qonuni (Amdahl's law): agar dasturning p ulushi tezlashtirilsa va qolgan 1−p ulushi o'zgarmasa, umumiy tezlashuv S = 1 / ((1−p) + p/s) dan oshmaydi, bu yerda s — tezlashtirilgan qismning tezlashuvi. Video-analitikada inferens kadr vaqtining 60 % ini egallasa va uni cheksiz tezlashtirsak ham, umumiy tezlashuv 2,5 baravardan oshmaydi — dekodlash va keyingi ishlov cheklaydi. Roofline modeli esa yukning arifmetik intensivligi (FLOP / bayt) asosida u hisoblash yoki xotira bilan cheklanganini ko'rsatadi; bu model M10 da batafsil ko'riladi, lekin co-design ning har bir qadamida ishlatiladi.</a:t>
+            </a:r>
+          </a:p>
+        </p:txBody>
+      </p:sp>
+      <p:sp>
+        <p:nvSpPr>
+          <p:cNvPr id="4" name="Slide Number Placeholder 3"/>
+          <p:cNvSpPr>
+            <a:spLocks noGrp="1"/>
+          </p:cNvSpPr>
+          <p:nvPr>
+            <p:ph type="sldNum" idx="5" sz="quarter"/>
+          </p:nvPr>
+        </p:nvSpPr>
+        <p:spPr/>
+      </p:sp>
+    </p:spTree>
+  </p:cSld>
+  <p:clrMapOvr>
+    <a:masterClrMapping/>
+  </p:clrMapOvr>
+</p:notes>
+</file>
+
+<file path=ppt/notesSlides/notesSlide7.xml><?xml version="1.0" encoding="utf-8"?>
 <p:notes xmlns:a="http://schemas.openxmlformats.org/drawingml/2006/main" xmlns:p="http://schemas.openxmlformats.org/presentationml/2006/main" xmlns:r="http://schemas.openxmlformats.org/officeDocument/2006/relationships">
   <p:cSld>
     <p:spTree>
@@ -5681,7 +5800,7 @@
                 </a:solidFill>
                 <a:latin typeface="Calibri"/>
               </a:rPr>
-              <a:t>AI-enabled computer systems arxitekturasi (1)</a:t>
+              <a:t>AI-enabled computer systems arxitekturasi</a:t>
             </a:r>
           </a:p>
         </p:txBody>
@@ -5808,12 +5927,12 @@
         </p:nvSpPr>
         <p:spPr>
           <a:xfrm>
-            <a:off x="550000" y="1300000"/>
-            <a:ext cx="11100000" cy="894000"/>
+            <a:off x="550000" y="1441240"/>
+            <a:ext cx="11100000" cy="1084380"/>
           </a:xfrm>
           <a:prstGeom prst="roundRect">
             <a:avLst>
-              <a:gd name="adj" fmla="val 18000"/>
+              <a:gd name="adj" fmla="val 8000"/>
             </a:avLst>
           </a:prstGeom>
           <a:solidFill>
@@ -5854,8 +5973,8 @@
         </p:nvSpPr>
         <p:spPr>
           <a:xfrm>
-            <a:off x="550000" y="1300000"/>
-            <a:ext cx="70000" cy="894000"/>
+            <a:off x="550000" y="1441240"/>
+            <a:ext cx="70000" cy="1084380"/>
           </a:xfrm>
           <a:prstGeom prst="rect">
             <a:avLst/>
@@ -5898,8 +6017,8 @@
         </p:nvSpPr>
         <p:spPr>
           <a:xfrm>
-            <a:off x="800000" y="1517000"/>
-            <a:ext cx="460000" cy="460000"/>
+            <a:off x="780000" y="1773430"/>
+            <a:ext cx="420000" cy="420000"/>
           </a:xfrm>
           <a:prstGeom prst="ellipse">
             <a:avLst/>
@@ -5932,7 +6051,7 @@
           <a:p>
             <a:pPr algn="ctr"/>
             <a:r>
-              <a:rPr sz="1600" b="1">
+              <a:rPr sz="1400" b="1">
                 <a:solidFill>
                   <a:srgbClr val="FFFFFF"/>
                 </a:solidFill>
@@ -5951,8 +6070,8 @@
         </p:nvSpPr>
         <p:spPr>
           <a:xfrm>
-            <a:off x="1450000" y="1300000"/>
-            <a:ext cx="10050000" cy="894000"/>
+            <a:off x="1380000" y="1481240"/>
+            <a:ext cx="10150000" cy="1004380"/>
           </a:xfrm>
           <a:prstGeom prst="rect">
             <a:avLst/>
@@ -5960,22 +6079,37 @@
           <a:noFill/>
         </p:spPr>
         <p:txBody>
-          <a:bodyPr wrap="square" anchor="ctr" lIns="50800" rIns="50800">
+          <a:bodyPr wrap="square" anchor="ctr">
             <a:spAutoFit/>
           </a:bodyPr>
           <a:lstStyle/>
           <a:p>
-            <a:pPr algn="l"/>
             <a:r>
-              <a:rPr sz="1400" b="0">
+              <a:rPr sz="1600" b="1">
                 <a:solidFill>
-                  <a:srgbClr val="1B2430"/>
+                  <a:srgbClr val="1F3A5F"/>
                 </a:solidFill>
                 <a:latin typeface="Calibri"/>
               </a:rPr>
               <a:t>AI-enabled kompyuter tizimi — bu funksionalligining muhim qismi o'qitilgan model orqali amalga oshiriladigan tizim.</a:t>
             </a:r>
           </a:p>
+          <a:p>
+            <a:pPr>
+              <a:spcBef>
+                <a:spcPts val="400"/>
+              </a:spcBef>
+            </a:pPr>
+            <a:r>
+              <a:rPr sz="1500">
+                <a:solidFill>
+                  <a:srgbClr val="334055"/>
+                </a:solidFill>
+                <a:latin typeface="Calibri"/>
+              </a:rPr>
+              <a:t>Uning arxitekturasini besh qatlamli model sifatida tasavvur qilish qulay:</a:t>
+            </a:r>
+          </a:p>
         </p:txBody>
       </p:sp>
       <p:sp>
@@ -5986,12 +6120,12 @@
         </p:nvSpPr>
         <p:spPr>
           <a:xfrm>
-            <a:off x="550000" y="2314000"/>
-            <a:ext cx="11100000" cy="894000"/>
+            <a:off x="550000" y="2635620"/>
+            <a:ext cx="11100000" cy="1084380"/>
           </a:xfrm>
           <a:prstGeom prst="roundRect">
             <a:avLst>
-              <a:gd name="adj" fmla="val 18000"/>
+              <a:gd name="adj" fmla="val 8000"/>
             </a:avLst>
           </a:prstGeom>
           <a:solidFill>
@@ -6032,8 +6166,8 @@
         </p:nvSpPr>
         <p:spPr>
           <a:xfrm>
-            <a:off x="550000" y="2314000"/>
-            <a:ext cx="70000" cy="894000"/>
+            <a:off x="550000" y="2635620"/>
+            <a:ext cx="70000" cy="1084380"/>
           </a:xfrm>
           <a:prstGeom prst="rect">
             <a:avLst/>
@@ -6076,8 +6210,8 @@
         </p:nvSpPr>
         <p:spPr>
           <a:xfrm>
-            <a:off x="800000" y="2531000"/>
-            <a:ext cx="460000" cy="460000"/>
+            <a:off x="780000" y="2967810"/>
+            <a:ext cx="420000" cy="420000"/>
           </a:xfrm>
           <a:prstGeom prst="ellipse">
             <a:avLst/>
@@ -6110,7 +6244,7 @@
           <a:p>
             <a:pPr algn="ctr"/>
             <a:r>
-              <a:rPr sz="1600" b="1">
+              <a:rPr sz="1400" b="1">
                 <a:solidFill>
                   <a:srgbClr val="FFFFFF"/>
                 </a:solidFill>
@@ -6129,8 +6263,8 @@
         </p:nvSpPr>
         <p:spPr>
           <a:xfrm>
-            <a:off x="1450000" y="2314000"/>
-            <a:ext cx="10050000" cy="894000"/>
+            <a:off x="1380000" y="2675620"/>
+            <a:ext cx="10150000" cy="1004380"/>
           </a:xfrm>
           <a:prstGeom prst="rect">
             <a:avLst/>
@@ -6138,20 +6272,35 @@
           <a:noFill/>
         </p:spPr>
         <p:txBody>
-          <a:bodyPr wrap="square" anchor="ctr" lIns="50800" rIns="50800">
+          <a:bodyPr wrap="square" anchor="ctr">
             <a:spAutoFit/>
           </a:bodyPr>
           <a:lstStyle/>
           <a:p>
-            <a:pPr algn="l"/>
             <a:r>
-              <a:rPr sz="1400" b="0">
+              <a:rPr sz="1600" b="1">
                 <a:solidFill>
-                  <a:srgbClr val="1B2430"/>
+                  <a:srgbClr val="1F3A5F"/>
                 </a:solidFill>
                 <a:latin typeface="Calibri"/>
               </a:rPr>
-              <a:t>Ma'lumot qabul qilish qatlami (ingestion) — sensorlar, kameralar, jurnallar, foydalanuvchi so'rovlari. Bu yerda protokollar (RTSP, MQTT, HTTP/gRPC), kodeklar (H.264/H.265) va buferlash hal…</a:t>
+              <a:t>Ma'lumot qabul qilish qatlami (ingestion).</a:t>
+            </a:r>
+          </a:p>
+          <a:p>
+            <a:pPr>
+              <a:spcBef>
+                <a:spcPts val="400"/>
+              </a:spcBef>
+            </a:pPr>
+            <a:r>
+              <a:rPr sz="1500">
+                <a:solidFill>
+                  <a:srgbClr val="334055"/>
+                </a:solidFill>
+                <a:latin typeface="Calibri"/>
+              </a:rPr>
+              <a:t>sensorlar, kameralar, jurnallar, foydalanuvchi so'rovlari. Bu yerda protokollar (RTSP, MQTT, HTTP/gRPC), kodeklar (H.264/H.265) va buferlash hal qilinadi.</a:t>
             </a:r>
           </a:p>
         </p:txBody>
@@ -6164,12 +6313,12 @@
         </p:nvSpPr>
         <p:spPr>
           <a:xfrm>
-            <a:off x="550000" y="3328000"/>
-            <a:ext cx="11100000" cy="894000"/>
+            <a:off x="550000" y="3830000"/>
+            <a:ext cx="11100000" cy="1084380"/>
           </a:xfrm>
           <a:prstGeom prst="roundRect">
             <a:avLst>
-              <a:gd name="adj" fmla="val 18000"/>
+              <a:gd name="adj" fmla="val 8000"/>
             </a:avLst>
           </a:prstGeom>
           <a:solidFill>
@@ -6210,8 +6359,8 @@
         </p:nvSpPr>
         <p:spPr>
           <a:xfrm>
-            <a:off x="550000" y="3328000"/>
-            <a:ext cx="70000" cy="894000"/>
+            <a:off x="550000" y="3830000"/>
+            <a:ext cx="70000" cy="1084380"/>
           </a:xfrm>
           <a:prstGeom prst="rect">
             <a:avLst/>
@@ -6254,8 +6403,8 @@
         </p:nvSpPr>
         <p:spPr>
           <a:xfrm>
-            <a:off x="800000" y="3545000"/>
-            <a:ext cx="460000" cy="460000"/>
+            <a:off x="780000" y="4162190"/>
+            <a:ext cx="420000" cy="420000"/>
           </a:xfrm>
           <a:prstGeom prst="ellipse">
             <a:avLst/>
@@ -6288,7 +6437,7 @@
           <a:p>
             <a:pPr algn="ctr"/>
             <a:r>
-              <a:rPr sz="1600" b="1">
+              <a:rPr sz="1400" b="1">
                 <a:solidFill>
                   <a:srgbClr val="FFFFFF"/>
                 </a:solidFill>
@@ -6307,8 +6456,8 @@
         </p:nvSpPr>
         <p:spPr>
           <a:xfrm>
-            <a:off x="1450000" y="3328000"/>
-            <a:ext cx="10050000" cy="894000"/>
+            <a:off x="1380000" y="3870000"/>
+            <a:ext cx="10150000" cy="1004380"/>
           </a:xfrm>
           <a:prstGeom prst="rect">
             <a:avLst/>
@@ -6316,20 +6465,35 @@
           <a:noFill/>
         </p:spPr>
         <p:txBody>
-          <a:bodyPr wrap="square" anchor="ctr" lIns="50800" rIns="50800">
+          <a:bodyPr wrap="square" anchor="ctr">
             <a:spAutoFit/>
           </a:bodyPr>
           <a:lstStyle/>
           <a:p>
-            <a:pPr algn="l"/>
             <a:r>
-              <a:rPr sz="1400" b="0">
+              <a:rPr sz="1600" b="1">
                 <a:solidFill>
-                  <a:srgbClr val="1B2430"/>
+                  <a:srgbClr val="1F3A5F"/>
                 </a:solidFill>
                 <a:latin typeface="Calibri"/>
               </a:rPr>
-              <a:t>Oldindan ishlov berish qatlami (preprocessing) — dekodlash, o'lchamini o'zgartirish, normallashtirish, tokenlashtirish. Ko'pincha e'tibordan chetda qoladi, lekin video tizimlarida dekodlash…</a:t>
+              <a:t>Oldindan ishlov berish qatlami (preprocessing).</a:t>
+            </a:r>
+          </a:p>
+          <a:p>
+            <a:pPr>
+              <a:spcBef>
+                <a:spcPts val="400"/>
+              </a:spcBef>
+            </a:pPr>
+            <a:r>
+              <a:rPr sz="1500">
+                <a:solidFill>
+                  <a:srgbClr val="334055"/>
+                </a:solidFill>
+                <a:latin typeface="Calibri"/>
+              </a:rPr>
+              <a:t>dekodlash, o'lchamini o'zgartirish, normallashtirish, tokenlashtirish. Ko'pincha e'tibordan chetda qoladi, lekin video tizimlarida dekodlash inferensdan ko'ra ko'proq resurs talab qilishi mumkin.</a:t>
             </a:r>
           </a:p>
         </p:txBody>
@@ -6342,12 +6506,12 @@
         </p:nvSpPr>
         <p:spPr>
           <a:xfrm>
-            <a:off x="550000" y="4342000"/>
-            <a:ext cx="11100000" cy="894000"/>
+            <a:off x="550000" y="5024380"/>
+            <a:ext cx="11100000" cy="1084380"/>
           </a:xfrm>
           <a:prstGeom prst="roundRect">
             <a:avLst>
-              <a:gd name="adj" fmla="val 18000"/>
+              <a:gd name="adj" fmla="val 8000"/>
             </a:avLst>
           </a:prstGeom>
           <a:solidFill>
@@ -6388,8 +6552,8 @@
         </p:nvSpPr>
         <p:spPr>
           <a:xfrm>
-            <a:off x="550000" y="4342000"/>
-            <a:ext cx="70000" cy="894000"/>
+            <a:off x="550000" y="5024380"/>
+            <a:ext cx="70000" cy="1084380"/>
           </a:xfrm>
           <a:prstGeom prst="rect">
             <a:avLst/>
@@ -6432,8 +6596,8 @@
         </p:nvSpPr>
         <p:spPr>
           <a:xfrm>
-            <a:off x="800000" y="4559000"/>
-            <a:ext cx="460000" cy="460000"/>
+            <a:off x="780000" y="5356570"/>
+            <a:ext cx="420000" cy="420000"/>
           </a:xfrm>
           <a:prstGeom prst="ellipse">
             <a:avLst/>
@@ -6466,7 +6630,7 @@
           <a:p>
             <a:pPr algn="ctr"/>
             <a:r>
-              <a:rPr sz="1600" b="1">
+              <a:rPr sz="1400" b="1">
                 <a:solidFill>
                   <a:srgbClr val="FFFFFF"/>
                 </a:solidFill>
@@ -6485,8 +6649,8 @@
         </p:nvSpPr>
         <p:spPr>
           <a:xfrm>
-            <a:off x="1450000" y="4342000"/>
-            <a:ext cx="10050000" cy="894000"/>
+            <a:off x="1380000" y="5064380"/>
+            <a:ext cx="10150000" cy="1004380"/>
           </a:xfrm>
           <a:prstGeom prst="rect">
             <a:avLst/>
@@ -6494,198 +6658,35 @@
           <a:noFill/>
         </p:spPr>
         <p:txBody>
-          <a:bodyPr wrap="square" anchor="ctr" lIns="50800" rIns="50800">
+          <a:bodyPr wrap="square" anchor="ctr">
             <a:spAutoFit/>
           </a:bodyPr>
           <a:lstStyle/>
           <a:p>
-            <a:pPr algn="l"/>
             <a:r>
-              <a:rPr sz="1400" b="0">
+              <a:rPr sz="1600" b="1">
                 <a:solidFill>
-                  <a:srgbClr val="1B2430"/>
+                  <a:srgbClr val="1F3A5F"/>
                 </a:solidFill>
                 <a:latin typeface="Calibri"/>
               </a:rPr>
-              <a:t>Inferens qatlami — modelning o'zi va uni bajaruvchi ish vaqti muhiti (PyTorch, ONNX Runtime, TensorRT, OpenVINO). Bu qatlam tezlatkich bilan bevosita ishlaydi.</a:t>
+              <a:t>Inferens qatlami.</a:t>
             </a:r>
           </a:p>
-        </p:txBody>
-      </p:sp>
-      <p:sp>
-        <p:nvSpPr>
-          <p:cNvPr id="26" name="Rounded Rectangle 25"/>
-          <p:cNvSpPr/>
-          <p:nvPr/>
-        </p:nvSpPr>
-        <p:spPr>
-          <a:xfrm>
-            <a:off x="550000" y="5356000"/>
-            <a:ext cx="11100000" cy="894000"/>
-          </a:xfrm>
-          <a:prstGeom prst="roundRect">
-            <a:avLst>
-              <a:gd name="adj" fmla="val 18000"/>
-            </a:avLst>
-          </a:prstGeom>
-          <a:solidFill>
-            <a:srgbClr val="F5F8FC"/>
-          </a:solidFill>
-          <a:ln>
-            <a:noFill/>
-          </a:ln>
-          <a:effectLst/>
-        </p:spPr>
-        <p:style>
-          <a:lnRef idx="1">
-            <a:schemeClr val="accent1"/>
-          </a:lnRef>
-          <a:fillRef idx="3">
-            <a:schemeClr val="accent1"/>
-          </a:fillRef>
-          <a:effectRef idx="2">
-            <a:schemeClr val="accent1"/>
-          </a:effectRef>
-          <a:fontRef idx="minor">
-            <a:schemeClr val="lt1"/>
-          </a:fontRef>
-        </p:style>
-        <p:txBody>
-          <a:bodyPr rtlCol="0" anchor="ctr"/>
-          <a:lstStyle/>
-          <a:p>
-            <a:pPr algn="ctr"/>
-          </a:p>
-        </p:txBody>
-      </p:sp>
-      <p:sp>
-        <p:nvSpPr>
-          <p:cNvPr id="27" name="Rectangle 26"/>
-          <p:cNvSpPr/>
-          <p:nvPr/>
-        </p:nvSpPr>
-        <p:spPr>
-          <a:xfrm>
-            <a:off x="550000" y="5356000"/>
-            <a:ext cx="70000" cy="894000"/>
-          </a:xfrm>
-          <a:prstGeom prst="rect">
-            <a:avLst/>
-          </a:prstGeom>
-          <a:solidFill>
-            <a:srgbClr val="C0392B"/>
-          </a:solidFill>
-          <a:ln>
-            <a:noFill/>
-          </a:ln>
-          <a:effectLst/>
-        </p:spPr>
-        <p:style>
-          <a:lnRef idx="1">
-            <a:schemeClr val="accent1"/>
-          </a:lnRef>
-          <a:fillRef idx="3">
-            <a:schemeClr val="accent1"/>
-          </a:fillRef>
-          <a:effectRef idx="2">
-            <a:schemeClr val="accent1"/>
-          </a:effectRef>
-          <a:fontRef idx="minor">
-            <a:schemeClr val="lt1"/>
-          </a:fontRef>
-        </p:style>
-        <p:txBody>
-          <a:bodyPr rtlCol="0" anchor="ctr"/>
-          <a:lstStyle/>
-          <a:p>
-            <a:pPr algn="ctr"/>
-          </a:p>
-        </p:txBody>
-      </p:sp>
-      <p:sp>
-        <p:nvSpPr>
-          <p:cNvPr id="28" name="Oval 27"/>
-          <p:cNvSpPr/>
-          <p:nvPr/>
-        </p:nvSpPr>
-        <p:spPr>
-          <a:xfrm>
-            <a:off x="800000" y="5573000"/>
-            <a:ext cx="460000" cy="460000"/>
-          </a:xfrm>
-          <a:prstGeom prst="ellipse">
-            <a:avLst/>
-          </a:prstGeom>
-          <a:solidFill>
-            <a:srgbClr val="C0392B"/>
-          </a:solidFill>
-          <a:ln>
-            <a:noFill/>
-          </a:ln>
-          <a:effectLst/>
-        </p:spPr>
-        <p:style>
-          <a:lnRef idx="1">
-            <a:schemeClr val="accent1"/>
-          </a:lnRef>
-          <a:fillRef idx="3">
-            <a:schemeClr val="accent1"/>
-          </a:fillRef>
-          <a:effectRef idx="2">
-            <a:schemeClr val="accent1"/>
-          </a:effectRef>
-          <a:fontRef idx="minor">
-            <a:schemeClr val="lt1"/>
-          </a:fontRef>
-        </p:style>
-        <p:txBody>
-          <a:bodyPr rtlCol="0" anchor="ctr" lIns="0" rIns="0"/>
-          <a:lstStyle/>
-          <a:p>
-            <a:pPr algn="ctr"/>
+          <a:p>
+            <a:pPr>
+              <a:spcBef>
+                <a:spcPts val="400"/>
+              </a:spcBef>
+            </a:pPr>
             <a:r>
-              <a:rPr sz="1600" b="1">
+              <a:rPr sz="1500">
                 <a:solidFill>
-                  <a:srgbClr val="FFFFFF"/>
+                  <a:srgbClr val="334055"/>
                 </a:solidFill>
                 <a:latin typeface="Calibri"/>
               </a:rPr>
-              <a:t>5</a:t>
-            </a:r>
-          </a:p>
-        </p:txBody>
-      </p:sp>
-      <p:sp>
-        <p:nvSpPr>
-          <p:cNvPr id="29" name="TextBox 28"/>
-          <p:cNvSpPr txBox="1"/>
-          <p:nvPr/>
-        </p:nvSpPr>
-        <p:spPr>
-          <a:xfrm>
-            <a:off x="1450000" y="5356000"/>
-            <a:ext cx="10050000" cy="894000"/>
-          </a:xfrm>
-          <a:prstGeom prst="rect">
-            <a:avLst/>
-          </a:prstGeom>
-          <a:noFill/>
-        </p:spPr>
-        <p:txBody>
-          <a:bodyPr wrap="square" anchor="ctr" lIns="50800" rIns="50800">
-            <a:spAutoFit/>
-          </a:bodyPr>
-          <a:lstStyle/>
-          <a:p>
-            <a:pPr algn="l"/>
-            <a:r>
-              <a:rPr sz="1400" b="0">
-                <a:solidFill>
-                  <a:srgbClr val="1B2430"/>
-                </a:solidFill>
-                <a:latin typeface="Calibri"/>
-              </a:rPr>
-              <a:t>Orkestratsiya va biznes mantiq qatlami — natijalarni birlashtirish, qoidalar, kuzatish (tracking), hodisalarni yaratish, saqlash, boshqa tizimlarga uzatish.</a:t>
+              <a:t>modelning o'zi va uni bajaruvchi ish vaqti muhiti (PyTorch, ONNX Runtime, TensorRT, OpenVINO). Bu qatlam tezlatkich bilan bevosita ishlaydi.</a:t>
             </a:r>
           </a:p>
         </p:txBody>
@@ -6707,7 +6708,7 @@
               <p:cTn id="2" dur="indefinite" nodeType="mainSeq">
                 <p:childTnLst>
                   <p:par>
-                    <p:cTn id="127" fill="hold">
+                    <p:cTn id="103" fill="hold">
                       <p:stCondLst>
                         <p:cond delay="indefinite"/>
                         <p:cond evt="onBegin" delay="0">
@@ -8175,366 +8176,6 @@
                                         <p:cTn id="102" dur="550" fill="hold"/>
                                         <p:tgtEl>
                                           <p:spTgt spid="25"/>
-                                        </p:tgtEl>
-                                        <p:attrNameLst>
-                                          <p:attrName>ppt_y</p:attrName>
-                                        </p:attrNameLst>
-                                      </p:cBhvr>
-                                      <p:tavLst>
-                                        <p:tav tm="0">
-                                          <p:val>
-                                            <p:strVal val="#ppt_y+.08"/>
-                                          </p:val>
-                                        </p:tav>
-                                        <p:tav tm="100000">
-                                          <p:val>
-                                            <p:strVal val="#ppt_y"/>
-                                          </p:val>
-                                        </p:tav>
-                                      </p:tavLst>
-                                    </p:anim>
-                                  </p:childTnLst>
-                                </p:cTn>
-                              </p:par>
-                            </p:childTnLst>
-                          </p:cTn>
-                        </p:par>
-                        <p:par>
-                          <p:cTn id="103" fill="hold">
-                            <p:stCondLst>
-                              <p:cond delay="1100"/>
-                            </p:stCondLst>
-                            <p:childTnLst>
-                              <p:par>
-                                <p:cTn id="104" presetID="42" presetClass="entr" presetSubtype="0" fill="hold" grpId="0" nodeType="afterEffect">
-                                  <p:stCondLst>
-                                    <p:cond delay="0"/>
-                                  </p:stCondLst>
-                                  <p:childTnLst>
-                                    <p:set>
-                                      <p:cBhvr>
-                                        <p:cTn id="105" dur="1" fill="hold">
-                                          <p:stCondLst>
-                                            <p:cond delay="0"/>
-                                          </p:stCondLst>
-                                        </p:cTn>
-                                        <p:tgtEl>
-                                          <p:spTgt spid="26"/>
-                                        </p:tgtEl>
-                                        <p:attrNameLst>
-                                          <p:attrName>style.visibility</p:attrName>
-                                        </p:attrNameLst>
-                                      </p:cBhvr>
-                                      <p:to>
-                                        <p:strVal val="visible"/>
-                                      </p:to>
-                                    </p:set>
-                                    <p:animEffect transition="in" filter="fade">
-                                      <p:cBhvr>
-                                        <p:cTn id="106" dur="550"/>
-                                        <p:tgtEl>
-                                          <p:spTgt spid="26"/>
-                                        </p:tgtEl>
-                                      </p:cBhvr>
-                                    </p:animEffect>
-                                    <p:anim calcmode="lin" valueType="num">
-                                      <p:cBhvr additive="base">
-                                        <p:cTn id="107" dur="550" fill="hold"/>
-                                        <p:tgtEl>
-                                          <p:spTgt spid="26"/>
-                                        </p:tgtEl>
-                                        <p:attrNameLst>
-                                          <p:attrName>ppt_x</p:attrName>
-                                        </p:attrNameLst>
-                                      </p:cBhvr>
-                                      <p:tavLst>
-                                        <p:tav tm="0">
-                                          <p:val>
-                                            <p:strVal val="#ppt_x"/>
-                                          </p:val>
-                                        </p:tav>
-                                        <p:tav tm="100000">
-                                          <p:val>
-                                            <p:strVal val="#ppt_x"/>
-                                          </p:val>
-                                        </p:tav>
-                                      </p:tavLst>
-                                    </p:anim>
-                                    <p:anim calcmode="lin" valueType="num">
-                                      <p:cBhvr additive="base">
-                                        <p:cTn id="108" dur="550" fill="hold"/>
-                                        <p:tgtEl>
-                                          <p:spTgt spid="26"/>
-                                        </p:tgtEl>
-                                        <p:attrNameLst>
-                                          <p:attrName>ppt_y</p:attrName>
-                                        </p:attrNameLst>
-                                      </p:cBhvr>
-                                      <p:tavLst>
-                                        <p:tav tm="0">
-                                          <p:val>
-                                            <p:strVal val="#ppt_y+.08"/>
-                                          </p:val>
-                                        </p:tav>
-                                        <p:tav tm="100000">
-                                          <p:val>
-                                            <p:strVal val="#ppt_y"/>
-                                          </p:val>
-                                        </p:tav>
-                                      </p:tavLst>
-                                    </p:anim>
-                                  </p:childTnLst>
-                                </p:cTn>
-                              </p:par>
-                            </p:childTnLst>
-                          </p:cTn>
-                        </p:par>
-                        <p:par>
-                          <p:cTn id="109" fill="hold">
-                            <p:stCondLst>
-                              <p:cond delay="1100"/>
-                            </p:stCondLst>
-                            <p:childTnLst>
-                              <p:par>
-                                <p:cTn id="110" presetID="42" presetClass="entr" presetSubtype="0" fill="hold" grpId="0" nodeType="afterEffect">
-                                  <p:stCondLst>
-                                    <p:cond delay="0"/>
-                                  </p:stCondLst>
-                                  <p:childTnLst>
-                                    <p:set>
-                                      <p:cBhvr>
-                                        <p:cTn id="111" dur="1" fill="hold">
-                                          <p:stCondLst>
-                                            <p:cond delay="0"/>
-                                          </p:stCondLst>
-                                        </p:cTn>
-                                        <p:tgtEl>
-                                          <p:spTgt spid="27"/>
-                                        </p:tgtEl>
-                                        <p:attrNameLst>
-                                          <p:attrName>style.visibility</p:attrName>
-                                        </p:attrNameLst>
-                                      </p:cBhvr>
-                                      <p:to>
-                                        <p:strVal val="visible"/>
-                                      </p:to>
-                                    </p:set>
-                                    <p:animEffect transition="in" filter="fade">
-                                      <p:cBhvr>
-                                        <p:cTn id="112" dur="550"/>
-                                        <p:tgtEl>
-                                          <p:spTgt spid="27"/>
-                                        </p:tgtEl>
-                                      </p:cBhvr>
-                                    </p:animEffect>
-                                    <p:anim calcmode="lin" valueType="num">
-                                      <p:cBhvr additive="base">
-                                        <p:cTn id="113" dur="550" fill="hold"/>
-                                        <p:tgtEl>
-                                          <p:spTgt spid="27"/>
-                                        </p:tgtEl>
-                                        <p:attrNameLst>
-                                          <p:attrName>ppt_x</p:attrName>
-                                        </p:attrNameLst>
-                                      </p:cBhvr>
-                                      <p:tavLst>
-                                        <p:tav tm="0">
-                                          <p:val>
-                                            <p:strVal val="#ppt_x"/>
-                                          </p:val>
-                                        </p:tav>
-                                        <p:tav tm="100000">
-                                          <p:val>
-                                            <p:strVal val="#ppt_x"/>
-                                          </p:val>
-                                        </p:tav>
-                                      </p:tavLst>
-                                    </p:anim>
-                                    <p:anim calcmode="lin" valueType="num">
-                                      <p:cBhvr additive="base">
-                                        <p:cTn id="114" dur="550" fill="hold"/>
-                                        <p:tgtEl>
-                                          <p:spTgt spid="27"/>
-                                        </p:tgtEl>
-                                        <p:attrNameLst>
-                                          <p:attrName>ppt_y</p:attrName>
-                                        </p:attrNameLst>
-                                      </p:cBhvr>
-                                      <p:tavLst>
-                                        <p:tav tm="0">
-                                          <p:val>
-                                            <p:strVal val="#ppt_y+.08"/>
-                                          </p:val>
-                                        </p:tav>
-                                        <p:tav tm="100000">
-                                          <p:val>
-                                            <p:strVal val="#ppt_y"/>
-                                          </p:val>
-                                        </p:tav>
-                                      </p:tavLst>
-                                    </p:anim>
-                                  </p:childTnLst>
-                                </p:cTn>
-                              </p:par>
-                            </p:childTnLst>
-                          </p:cTn>
-                        </p:par>
-                        <p:par>
-                          <p:cTn id="115" fill="hold">
-                            <p:stCondLst>
-                              <p:cond delay="1100"/>
-                            </p:stCondLst>
-                            <p:childTnLst>
-                              <p:par>
-                                <p:cTn id="116" presetID="53" presetClass="entr" presetSubtype="16" fill="hold" grpId="0" nodeType="afterEffect">
-                                  <p:stCondLst>
-                                    <p:cond delay="0"/>
-                                  </p:stCondLst>
-                                  <p:childTnLst>
-                                    <p:set>
-                                      <p:cBhvr>
-                                        <p:cTn id="117" dur="1" fill="hold">
-                                          <p:stCondLst>
-                                            <p:cond delay="0"/>
-                                          </p:stCondLst>
-                                        </p:cTn>
-                                        <p:tgtEl>
-                                          <p:spTgt spid="28"/>
-                                        </p:tgtEl>
-                                        <p:attrNameLst>
-                                          <p:attrName>style.visibility</p:attrName>
-                                        </p:attrNameLst>
-                                      </p:cBhvr>
-                                      <p:to>
-                                        <p:strVal val="visible"/>
-                                      </p:to>
-                                    </p:set>
-                                    <p:animEffect transition="in" filter="fade">
-                                      <p:cBhvr>
-                                        <p:cTn id="118" dur="550"/>
-                                        <p:tgtEl>
-                                          <p:spTgt spid="28"/>
-                                        </p:tgtEl>
-                                      </p:cBhvr>
-                                    </p:animEffect>
-                                    <p:anim calcmode="lin" valueType="num">
-                                      <p:cBhvr additive="base">
-                                        <p:cTn id="119" dur="550" fill="hold"/>
-                                        <p:tgtEl>
-                                          <p:spTgt spid="28"/>
-                                        </p:tgtEl>
-                                        <p:attrNameLst>
-                                          <p:attrName>ppt_w</p:attrName>
-                                        </p:attrNameLst>
-                                      </p:cBhvr>
-                                      <p:tavLst>
-                                        <p:tav tm="0">
-                                          <p:val>
-                                            <p:strVal val="0"/>
-                                          </p:val>
-                                        </p:tav>
-                                        <p:tav tm="100000">
-                                          <p:val>
-                                            <p:strVal val="#ppt_w"/>
-                                          </p:val>
-                                        </p:tav>
-                                      </p:tavLst>
-                                    </p:anim>
-                                    <p:anim calcmode="lin" valueType="num">
-                                      <p:cBhvr additive="base">
-                                        <p:cTn id="120" dur="550" fill="hold"/>
-                                        <p:tgtEl>
-                                          <p:spTgt spid="28"/>
-                                        </p:tgtEl>
-                                        <p:attrNameLst>
-                                          <p:attrName>ppt_h</p:attrName>
-                                        </p:attrNameLst>
-                                      </p:cBhvr>
-                                      <p:tavLst>
-                                        <p:tav tm="0">
-                                          <p:val>
-                                            <p:strVal val="0"/>
-                                          </p:val>
-                                        </p:tav>
-                                        <p:tav tm="100000">
-                                          <p:val>
-                                            <p:strVal val="#ppt_h"/>
-                                          </p:val>
-                                        </p:tav>
-                                      </p:tavLst>
-                                    </p:anim>
-                                  </p:childTnLst>
-                                </p:cTn>
-                              </p:par>
-                            </p:childTnLst>
-                          </p:cTn>
-                        </p:par>
-                        <p:par>
-                          <p:cTn id="121" fill="hold">
-                            <p:stCondLst>
-                              <p:cond delay="1100"/>
-                            </p:stCondLst>
-                            <p:childTnLst>
-                              <p:par>
-                                <p:cTn id="122" presetID="42" presetClass="entr" presetSubtype="0" fill="hold" grpId="0" nodeType="afterEffect">
-                                  <p:stCondLst>
-                                    <p:cond delay="0"/>
-                                  </p:stCondLst>
-                                  <p:childTnLst>
-                                    <p:set>
-                                      <p:cBhvr>
-                                        <p:cTn id="123" dur="1" fill="hold">
-                                          <p:stCondLst>
-                                            <p:cond delay="0"/>
-                                          </p:stCondLst>
-                                        </p:cTn>
-                                        <p:tgtEl>
-                                          <p:spTgt spid="29"/>
-                                        </p:tgtEl>
-                                        <p:attrNameLst>
-                                          <p:attrName>style.visibility</p:attrName>
-                                        </p:attrNameLst>
-                                      </p:cBhvr>
-                                      <p:to>
-                                        <p:strVal val="visible"/>
-                                      </p:to>
-                                    </p:set>
-                                    <p:animEffect transition="in" filter="fade">
-                                      <p:cBhvr>
-                                        <p:cTn id="124" dur="550"/>
-                                        <p:tgtEl>
-                                          <p:spTgt spid="29"/>
-                                        </p:tgtEl>
-                                      </p:cBhvr>
-                                    </p:animEffect>
-                                    <p:anim calcmode="lin" valueType="num">
-                                      <p:cBhvr additive="base">
-                                        <p:cTn id="125" dur="550" fill="hold"/>
-                                        <p:tgtEl>
-                                          <p:spTgt spid="29"/>
-                                        </p:tgtEl>
-                                        <p:attrNameLst>
-                                          <p:attrName>ppt_x</p:attrName>
-                                        </p:attrNameLst>
-                                      </p:cBhvr>
-                                      <p:tavLst>
-                                        <p:tav tm="0">
-                                          <p:val>
-                                            <p:strVal val="#ppt_x"/>
-                                          </p:val>
-                                        </p:tav>
-                                        <p:tav tm="100000">
-                                          <p:val>
-                                            <p:strVal val="#ppt_x"/>
-                                          </p:val>
-                                        </p:tav>
-                                      </p:tavLst>
-                                    </p:anim>
-                                    <p:anim calcmode="lin" valueType="num">
-                                      <p:cBhvr additive="base">
-                                        <p:cTn id="126" dur="550" fill="hold"/>
-                                        <p:tgtEl>
-                                          <p:spTgt spid="29"/>
                                         </p:tgtEl>
                                         <p:attrNameLst>
                                           <p:attrName>ppt_y</p:attrName>
@@ -8601,10 +8242,6 @@
       <p:bldP spid="23" grpId="0" animBg="1"/>
       <p:bldP spid="24" grpId="0" animBg="1"/>
       <p:bldP spid="25" grpId="0" animBg="1"/>
-      <p:bldP spid="26" grpId="0" animBg="1"/>
-      <p:bldP spid="27" grpId="0" animBg="1"/>
-      <p:bldP spid="28" grpId="0" animBg="1"/>
-      <p:bldP spid="29" grpId="0" animBg="1"/>
     </p:bldLst>
   </p:timing>
 </p:sld>
@@ -8825,7 +8462,7 @@
                 </a:solidFill>
                 <a:latin typeface="Calibri"/>
               </a:rPr>
-              <a:t>AI-enabled computer systems arxitekturasi (2)</a:t>
+              <a:t>AI-enabled computer systems arxitekturasi</a:t>
             </a:r>
           </a:p>
         </p:txBody>
@@ -8952,12 +8589,12 @@
         </p:nvSpPr>
         <p:spPr>
           <a:xfrm>
-            <a:off x="550000" y="1300000"/>
-            <a:ext cx="11100000" cy="1147500"/>
+            <a:off x="550000" y="1250000"/>
+            <a:ext cx="11100000" cy="1180000"/>
           </a:xfrm>
           <a:prstGeom prst="roundRect">
             <a:avLst>
-              <a:gd name="adj" fmla="val 18000"/>
+              <a:gd name="adj" fmla="val 8000"/>
             </a:avLst>
           </a:prstGeom>
           <a:solidFill>
@@ -8998,8 +8635,201 @@
         </p:nvSpPr>
         <p:spPr>
           <a:xfrm>
-            <a:off x="550000" y="1300000"/>
-            <a:ext cx="70000" cy="1147500"/>
+            <a:off x="550000" y="1250000"/>
+            <a:ext cx="70000" cy="1180000"/>
+          </a:xfrm>
+          <a:prstGeom prst="rect">
+            <a:avLst/>
+          </a:prstGeom>
+          <a:solidFill>
+            <a:srgbClr val="C0392B"/>
+          </a:solidFill>
+          <a:ln>
+            <a:noFill/>
+          </a:ln>
+          <a:effectLst/>
+        </p:spPr>
+        <p:style>
+          <a:lnRef idx="1">
+            <a:schemeClr val="accent1"/>
+          </a:lnRef>
+          <a:fillRef idx="3">
+            <a:schemeClr val="accent1"/>
+          </a:fillRef>
+          <a:effectRef idx="2">
+            <a:schemeClr val="accent1"/>
+          </a:effectRef>
+          <a:fontRef idx="minor">
+            <a:schemeClr val="lt1"/>
+          </a:fontRef>
+        </p:style>
+        <p:txBody>
+          <a:bodyPr rtlCol="0" anchor="ctr"/>
+          <a:lstStyle/>
+          <a:p>
+            <a:pPr algn="ctr"/>
+          </a:p>
+        </p:txBody>
+      </p:sp>
+      <p:sp>
+        <p:nvSpPr>
+          <p:cNvPr id="12" name="Oval 11"/>
+          <p:cNvSpPr/>
+          <p:nvPr/>
+        </p:nvSpPr>
+        <p:spPr>
+          <a:xfrm>
+            <a:off x="780000" y="1630000"/>
+            <a:ext cx="420000" cy="420000"/>
+          </a:xfrm>
+          <a:prstGeom prst="ellipse">
+            <a:avLst/>
+          </a:prstGeom>
+          <a:solidFill>
+            <a:srgbClr val="C0392B"/>
+          </a:solidFill>
+          <a:ln>
+            <a:noFill/>
+          </a:ln>
+          <a:effectLst/>
+        </p:spPr>
+        <p:style>
+          <a:lnRef idx="1">
+            <a:schemeClr val="accent1"/>
+          </a:lnRef>
+          <a:fillRef idx="3">
+            <a:schemeClr val="accent1"/>
+          </a:fillRef>
+          <a:effectRef idx="2">
+            <a:schemeClr val="accent1"/>
+          </a:effectRef>
+          <a:fontRef idx="minor">
+            <a:schemeClr val="lt1"/>
+          </a:fontRef>
+        </p:style>
+        <p:txBody>
+          <a:bodyPr rtlCol="0" anchor="ctr" lIns="0" rIns="0"/>
+          <a:lstStyle/>
+          <a:p>
+            <a:pPr algn="ctr"/>
+            <a:r>
+              <a:rPr sz="1400" b="1">
+                <a:solidFill>
+                  <a:srgbClr val="FFFFFF"/>
+                </a:solidFill>
+                <a:latin typeface="Calibri"/>
+              </a:rPr>
+              <a:t>5</a:t>
+            </a:r>
+          </a:p>
+        </p:txBody>
+      </p:sp>
+      <p:sp>
+        <p:nvSpPr>
+          <p:cNvPr id="13" name="TextBox 12"/>
+          <p:cNvSpPr txBox="1"/>
+          <p:nvPr/>
+        </p:nvSpPr>
+        <p:spPr>
+          <a:xfrm>
+            <a:off x="1380000" y="1290000"/>
+            <a:ext cx="10150000" cy="1100000"/>
+          </a:xfrm>
+          <a:prstGeom prst="rect">
+            <a:avLst/>
+          </a:prstGeom>
+          <a:noFill/>
+        </p:spPr>
+        <p:txBody>
+          <a:bodyPr wrap="square" anchor="ctr">
+            <a:spAutoFit/>
+          </a:bodyPr>
+          <a:lstStyle/>
+          <a:p>
+            <a:r>
+              <a:rPr sz="1500" b="1">
+                <a:solidFill>
+                  <a:srgbClr val="1F3A5F"/>
+                </a:solidFill>
+                <a:latin typeface="Calibri"/>
+              </a:rPr>
+              <a:t>Orkestratsiya va biznes mantiq qatlami.</a:t>
+            </a:r>
+          </a:p>
+          <a:p>
+            <a:pPr>
+              <a:spcBef>
+                <a:spcPts val="400"/>
+              </a:spcBef>
+            </a:pPr>
+            <a:r>
+              <a:rPr sz="1400">
+                <a:solidFill>
+                  <a:srgbClr val="334055"/>
+                </a:solidFill>
+                <a:latin typeface="Calibri"/>
+              </a:rPr>
+              <a:t>natijalarni birlashtirish, qoidalar, kuzatish (tracking), hodisalarni yaratish, saqlash, boshqa tizimlarga uzatish.</a:t>
+            </a:r>
+          </a:p>
+        </p:txBody>
+      </p:sp>
+      <p:sp>
+        <p:nvSpPr>
+          <p:cNvPr id="14" name="Rounded Rectangle 13"/>
+          <p:cNvSpPr/>
+          <p:nvPr/>
+        </p:nvSpPr>
+        <p:spPr>
+          <a:xfrm>
+            <a:off x="550000" y="2540000"/>
+            <a:ext cx="11100000" cy="1180000"/>
+          </a:xfrm>
+          <a:prstGeom prst="roundRect">
+            <a:avLst>
+              <a:gd name="adj" fmla="val 8000"/>
+            </a:avLst>
+          </a:prstGeom>
+          <a:solidFill>
+            <a:srgbClr val="F5F8FC"/>
+          </a:solidFill>
+          <a:ln>
+            <a:noFill/>
+          </a:ln>
+          <a:effectLst/>
+        </p:spPr>
+        <p:style>
+          <a:lnRef idx="1">
+            <a:schemeClr val="accent1"/>
+          </a:lnRef>
+          <a:fillRef idx="3">
+            <a:schemeClr val="accent1"/>
+          </a:fillRef>
+          <a:effectRef idx="2">
+            <a:schemeClr val="accent1"/>
+          </a:effectRef>
+          <a:fontRef idx="minor">
+            <a:schemeClr val="lt1"/>
+          </a:fontRef>
+        </p:style>
+        <p:txBody>
+          <a:bodyPr rtlCol="0" anchor="ctr"/>
+          <a:lstStyle/>
+          <a:p>
+            <a:pPr algn="ctr"/>
+          </a:p>
+        </p:txBody>
+      </p:sp>
+      <p:sp>
+        <p:nvSpPr>
+          <p:cNvPr id="15" name="Rectangle 14"/>
+          <p:cNvSpPr/>
+          <p:nvPr/>
+        </p:nvSpPr>
+        <p:spPr>
+          <a:xfrm>
+            <a:off x="550000" y="2540000"/>
+            <a:ext cx="70000" cy="1180000"/>
           </a:xfrm>
           <a:prstGeom prst="rect">
             <a:avLst/>
@@ -9036,14 +8866,14 @@
       </p:sp>
       <p:sp>
         <p:nvSpPr>
-          <p:cNvPr id="12" name="Oval 11"/>
+          <p:cNvPr id="16" name="Oval 15"/>
           <p:cNvSpPr/>
           <p:nvPr/>
         </p:nvSpPr>
         <p:spPr>
           <a:xfrm>
-            <a:off x="800000" y="1643750"/>
-            <a:ext cx="460000" cy="460000"/>
+            <a:off x="780000" y="2920000"/>
+            <a:ext cx="420000" cy="420000"/>
           </a:xfrm>
           <a:prstGeom prst="ellipse">
             <a:avLst/>
@@ -9076,7 +8906,7 @@
           <a:p>
             <a:pPr algn="ctr"/>
             <a:r>
-              <a:rPr sz="1600" b="1">
+              <a:rPr sz="1400" b="1">
                 <a:solidFill>
                   <a:srgbClr val="FFFFFF"/>
                 </a:solidFill>
@@ -9089,14 +8919,14 @@
       </p:sp>
       <p:sp>
         <p:nvSpPr>
-          <p:cNvPr id="13" name="TextBox 12"/>
+          <p:cNvPr id="17" name="TextBox 16"/>
           <p:cNvSpPr txBox="1"/>
           <p:nvPr/>
         </p:nvSpPr>
         <p:spPr>
           <a:xfrm>
-            <a:off x="1450000" y="1300000"/>
-            <a:ext cx="10050000" cy="1147500"/>
+            <a:off x="1380000" y="2580000"/>
+            <a:ext cx="10150000" cy="1100000"/>
           </a:xfrm>
           <a:prstGeom prst="rect">
             <a:avLst/>
@@ -9104,38 +8934,53 @@
           <a:noFill/>
         </p:spPr>
         <p:txBody>
-          <a:bodyPr wrap="square" anchor="ctr" lIns="50800" rIns="50800">
+          <a:bodyPr wrap="square" anchor="ctr">
             <a:spAutoFit/>
           </a:bodyPr>
           <a:lstStyle/>
           <a:p>
-            <a:pPr algn="l"/>
             <a:r>
-              <a:rPr sz="1400" b="0">
+              <a:rPr sz="1500" b="1">
                 <a:solidFill>
-                  <a:srgbClr val="1B2430"/>
+                  <a:srgbClr val="1F3A5F"/>
                 </a:solidFill>
                 <a:latin typeface="Calibri"/>
               </a:rPr>
-              <a:t>Kuzatuv va boshqaruv qatlami (observability) — metrikalar (kechikish, o'tkazuvchanlik, GPU bandligi), jurnallar, model sifati monitoringi, versiya boshqaruvi.</a:t>
+              <a:t>Kuzatuv va boshqaruv qatlami (observability).</a:t>
             </a:r>
           </a:p>
+          <a:p>
+            <a:pPr>
+              <a:spcBef>
+                <a:spcPts val="400"/>
+              </a:spcBef>
+            </a:pPr>
+            <a:r>
+              <a:rPr sz="1400">
+                <a:solidFill>
+                  <a:srgbClr val="334055"/>
+                </a:solidFill>
+                <a:latin typeface="Calibri"/>
+              </a:rPr>
+              <a:t>metrikalar (kechikish, o'tkazuvchanlik, GPU bandligi), jurnallar, model sifati monitoringi, versiya boshqaruvi.</a:t>
+            </a:r>
+          </a:p>
         </p:txBody>
       </p:sp>
       <p:sp>
         <p:nvSpPr>
-          <p:cNvPr id="14" name="Rounded Rectangle 13"/>
+          <p:cNvPr id="18" name="Rounded Rectangle 17"/>
           <p:cNvSpPr/>
           <p:nvPr/>
         </p:nvSpPr>
         <p:spPr>
           <a:xfrm>
-            <a:off x="550000" y="2567500"/>
-            <a:ext cx="11100000" cy="1147500"/>
+            <a:off x="550000" y="3830000"/>
+            <a:ext cx="11100000" cy="1180000"/>
           </a:xfrm>
           <a:prstGeom prst="roundRect">
             <a:avLst>
-              <a:gd name="adj" fmla="val 18000"/>
+              <a:gd name="adj" fmla="val 8000"/>
             </a:avLst>
           </a:prstGeom>
           <a:solidFill>
@@ -9170,14 +9015,14 @@
       </p:sp>
       <p:sp>
         <p:nvSpPr>
-          <p:cNvPr id="15" name="Rectangle 14"/>
+          <p:cNvPr id="19" name="Rectangle 18"/>
           <p:cNvSpPr/>
           <p:nvPr/>
         </p:nvSpPr>
         <p:spPr>
           <a:xfrm>
-            <a:off x="550000" y="2567500"/>
-            <a:ext cx="70000" cy="1147500"/>
+            <a:off x="550000" y="3830000"/>
+            <a:ext cx="70000" cy="1180000"/>
           </a:xfrm>
           <a:prstGeom prst="rect">
             <a:avLst/>
@@ -9214,14 +9059,14 @@
       </p:sp>
       <p:sp>
         <p:nvSpPr>
-          <p:cNvPr id="16" name="Oval 15"/>
+          <p:cNvPr id="20" name="Oval 19"/>
           <p:cNvSpPr/>
           <p:nvPr/>
         </p:nvSpPr>
         <p:spPr>
           <a:xfrm>
-            <a:off x="800000" y="2911250"/>
-            <a:ext cx="460000" cy="460000"/>
+            <a:off x="780000" y="4210000"/>
+            <a:ext cx="420000" cy="420000"/>
           </a:xfrm>
           <a:prstGeom prst="ellipse">
             <a:avLst/>
@@ -9254,7 +9099,7 @@
           <a:p>
             <a:pPr algn="ctr"/>
             <a:r>
-              <a:rPr sz="1600" b="1">
+              <a:rPr sz="1400" b="1">
                 <a:solidFill>
                   <a:srgbClr val="FFFFFF"/>
                 </a:solidFill>
@@ -9267,14 +9112,14 @@
       </p:sp>
       <p:sp>
         <p:nvSpPr>
-          <p:cNvPr id="17" name="TextBox 16"/>
+          <p:cNvPr id="21" name="TextBox 20"/>
           <p:cNvSpPr txBox="1"/>
           <p:nvPr/>
         </p:nvSpPr>
         <p:spPr>
           <a:xfrm>
-            <a:off x="1450000" y="2567500"/>
-            <a:ext cx="10050000" cy="1147500"/>
+            <a:off x="1380000" y="3870000"/>
+            <a:ext cx="10150000" cy="1100000"/>
           </a:xfrm>
           <a:prstGeom prst="rect">
             <a:avLst/>
@@ -9282,38 +9127,53 @@
           <a:noFill/>
         </p:spPr>
         <p:txBody>
-          <a:bodyPr wrap="square" anchor="ctr" lIns="50800" rIns="50800">
+          <a:bodyPr wrap="square" anchor="ctr">
             <a:spAutoFit/>
           </a:bodyPr>
           <a:lstStyle/>
           <a:p>
-            <a:pPr algn="l"/>
             <a:r>
-              <a:rPr sz="1400" b="0">
+              <a:rPr sz="1500" b="1">
                 <a:solidFill>
-                  <a:srgbClr val="1B2430"/>
+                  <a:srgbClr val="1F3A5F"/>
                 </a:solidFill>
                 <a:latin typeface="Calibri"/>
               </a:rPr>
-              <a:t>Qatlamlar orasidagi interfeyslar aniq belgilanishi kerak, chunki ular apparat chegaralari bilan mos tushadi: masalan, 1-2-qatlamlar CPU va video dekoder (NVDEC) da, 3-qatlam GPU da,…</a:t>
+              <a:t>Qatlamlar orasidagi interfeyslar aniq belgilanishi kerak, chunki ular apparat chegaralari bilan mos tushadi: masalan, 1-2-qatlamlar CPU va video dekoder (NVDEC) da, 3-qatlam GPU da, 4-5-qatlamlar CPU da ishlashi mumkin.</a:t>
             </a:r>
           </a:p>
+          <a:p>
+            <a:pPr>
+              <a:spcBef>
+                <a:spcPts val="400"/>
+              </a:spcBef>
+            </a:pPr>
+            <a:r>
+              <a:rPr sz="1400">
+                <a:solidFill>
+                  <a:srgbClr val="334055"/>
+                </a:solidFill>
+                <a:latin typeface="Calibri"/>
+              </a:rPr>
+              <a:t>Ma'lumotning bu chegaralardan o'tishi — xost va qurilma xotirasi o'rtasida nusxalash — ko'pincha asosiy to'siq (bottleneck) bo'ladi.</a:t>
+            </a:r>
+          </a:p>
         </p:txBody>
       </p:sp>
       <p:sp>
         <p:nvSpPr>
-          <p:cNvPr id="18" name="Rounded Rectangle 17"/>
+          <p:cNvPr id="22" name="Rounded Rectangle 21"/>
           <p:cNvSpPr/>
           <p:nvPr/>
         </p:nvSpPr>
         <p:spPr>
           <a:xfrm>
-            <a:off x="550000" y="3835000"/>
-            <a:ext cx="11100000" cy="1147500"/>
+            <a:off x="550000" y="5120000"/>
+            <a:ext cx="11100000" cy="1180000"/>
           </a:xfrm>
           <a:prstGeom prst="roundRect">
             <a:avLst>
-              <a:gd name="adj" fmla="val 18000"/>
+              <a:gd name="adj" fmla="val 8000"/>
             </a:avLst>
           </a:prstGeom>
           <a:solidFill>
@@ -9348,14 +9208,14 @@
       </p:sp>
       <p:sp>
         <p:nvSpPr>
-          <p:cNvPr id="19" name="Rectangle 18"/>
+          <p:cNvPr id="23" name="Rectangle 22"/>
           <p:cNvSpPr/>
           <p:nvPr/>
         </p:nvSpPr>
         <p:spPr>
           <a:xfrm>
-            <a:off x="550000" y="3835000"/>
-            <a:ext cx="70000" cy="1147500"/>
+            <a:off x="550000" y="5120000"/>
+            <a:ext cx="70000" cy="1180000"/>
           </a:xfrm>
           <a:prstGeom prst="rect">
             <a:avLst/>
@@ -9392,14 +9252,14 @@
       </p:sp>
       <p:sp>
         <p:nvSpPr>
-          <p:cNvPr id="20" name="Oval 19"/>
+          <p:cNvPr id="24" name="Oval 23"/>
           <p:cNvSpPr/>
           <p:nvPr/>
         </p:nvSpPr>
         <p:spPr>
           <a:xfrm>
-            <a:off x="800000" y="4178750"/>
-            <a:ext cx="460000" cy="460000"/>
+            <a:off x="780000" y="5500000"/>
+            <a:ext cx="420000" cy="420000"/>
           </a:xfrm>
           <a:prstGeom prst="ellipse">
             <a:avLst/>
@@ -9432,7 +9292,7 @@
           <a:p>
             <a:pPr algn="ctr"/>
             <a:r>
-              <a:rPr sz="1600" b="1">
+              <a:rPr sz="1400" b="1">
                 <a:solidFill>
                   <a:srgbClr val="FFFFFF"/>
                 </a:solidFill>
@@ -9445,14 +9305,14 @@
       </p:sp>
       <p:sp>
         <p:nvSpPr>
-          <p:cNvPr id="21" name="TextBox 20"/>
+          <p:cNvPr id="25" name="TextBox 24"/>
           <p:cNvSpPr txBox="1"/>
           <p:nvPr/>
         </p:nvSpPr>
         <p:spPr>
           <a:xfrm>
-            <a:off x="1450000" y="3835000"/>
-            <a:ext cx="10050000" cy="1147500"/>
+            <a:off x="1380000" y="5160000"/>
+            <a:ext cx="10150000" cy="1100000"/>
           </a:xfrm>
           <a:prstGeom prst="rect">
             <a:avLst/>
@@ -9460,198 +9320,35 @@
           <a:noFill/>
         </p:spPr>
         <p:txBody>
-          <a:bodyPr wrap="square" anchor="ctr" lIns="50800" rIns="50800">
+          <a:bodyPr wrap="square" anchor="ctr">
             <a:spAutoFit/>
           </a:bodyPr>
           <a:lstStyle/>
           <a:p>
-            <a:pPr algn="l"/>
             <a:r>
-              <a:rPr sz="1400" b="0">
+              <a:rPr sz="1500" b="1">
                 <a:solidFill>
-                  <a:srgbClr val="1B2430"/>
+                  <a:srgbClr val="1F3A5F"/>
                 </a:solidFill>
                 <a:latin typeface="Calibri"/>
               </a:rPr>
               <a:t>Arxitekturaning yana bir o'lchovi — inferens rejimi.</a:t>
             </a:r>
           </a:p>
-        </p:txBody>
-      </p:sp>
-      <p:sp>
-        <p:nvSpPr>
-          <p:cNvPr id="22" name="Rounded Rectangle 21"/>
-          <p:cNvSpPr/>
-          <p:nvPr/>
-        </p:nvSpPr>
-        <p:spPr>
-          <a:xfrm>
-            <a:off x="550000" y="5102500"/>
-            <a:ext cx="11100000" cy="1147500"/>
-          </a:xfrm>
-          <a:prstGeom prst="roundRect">
-            <a:avLst>
-              <a:gd name="adj" fmla="val 18000"/>
-            </a:avLst>
-          </a:prstGeom>
-          <a:solidFill>
-            <a:srgbClr val="F5F8FC"/>
-          </a:solidFill>
-          <a:ln>
-            <a:noFill/>
-          </a:ln>
-          <a:effectLst/>
-        </p:spPr>
-        <p:style>
-          <a:lnRef idx="1">
-            <a:schemeClr val="accent1"/>
-          </a:lnRef>
-          <a:fillRef idx="3">
-            <a:schemeClr val="accent1"/>
-          </a:fillRef>
-          <a:effectRef idx="2">
-            <a:schemeClr val="accent1"/>
-          </a:effectRef>
-          <a:fontRef idx="minor">
-            <a:schemeClr val="lt1"/>
-          </a:fontRef>
-        </p:style>
-        <p:txBody>
-          <a:bodyPr rtlCol="0" anchor="ctr"/>
-          <a:lstStyle/>
-          <a:p>
-            <a:pPr algn="ctr"/>
-          </a:p>
-        </p:txBody>
-      </p:sp>
-      <p:sp>
-        <p:nvSpPr>
-          <p:cNvPr id="23" name="Rectangle 22"/>
-          <p:cNvSpPr/>
-          <p:nvPr/>
-        </p:nvSpPr>
-        <p:spPr>
-          <a:xfrm>
-            <a:off x="550000" y="5102500"/>
-            <a:ext cx="70000" cy="1147500"/>
-          </a:xfrm>
-          <a:prstGeom prst="rect">
-            <a:avLst/>
-          </a:prstGeom>
-          <a:solidFill>
-            <a:srgbClr val="6A3FB5"/>
-          </a:solidFill>
-          <a:ln>
-            <a:noFill/>
-          </a:ln>
-          <a:effectLst/>
-        </p:spPr>
-        <p:style>
-          <a:lnRef idx="1">
-            <a:schemeClr val="accent1"/>
-          </a:lnRef>
-          <a:fillRef idx="3">
-            <a:schemeClr val="accent1"/>
-          </a:fillRef>
-          <a:effectRef idx="2">
-            <a:schemeClr val="accent1"/>
-          </a:effectRef>
-          <a:fontRef idx="minor">
-            <a:schemeClr val="lt1"/>
-          </a:fontRef>
-        </p:style>
-        <p:txBody>
-          <a:bodyPr rtlCol="0" anchor="ctr"/>
-          <a:lstStyle/>
-          <a:p>
-            <a:pPr algn="ctr"/>
-          </a:p>
-        </p:txBody>
-      </p:sp>
-      <p:sp>
-        <p:nvSpPr>
-          <p:cNvPr id="24" name="Oval 23"/>
-          <p:cNvSpPr/>
-          <p:nvPr/>
-        </p:nvSpPr>
-        <p:spPr>
-          <a:xfrm>
-            <a:off x="800000" y="5446250"/>
-            <a:ext cx="460000" cy="460000"/>
-          </a:xfrm>
-          <a:prstGeom prst="ellipse">
-            <a:avLst/>
-          </a:prstGeom>
-          <a:solidFill>
-            <a:srgbClr val="6A3FB5"/>
-          </a:solidFill>
-          <a:ln>
-            <a:noFill/>
-          </a:ln>
-          <a:effectLst/>
-        </p:spPr>
-        <p:style>
-          <a:lnRef idx="1">
-            <a:schemeClr val="accent1"/>
-          </a:lnRef>
-          <a:fillRef idx="3">
-            <a:schemeClr val="accent1"/>
-          </a:fillRef>
-          <a:effectRef idx="2">
-            <a:schemeClr val="accent1"/>
-          </a:effectRef>
-          <a:fontRef idx="minor">
-            <a:schemeClr val="lt1"/>
-          </a:fontRef>
-        </p:style>
-        <p:txBody>
-          <a:bodyPr rtlCol="0" anchor="ctr" lIns="0" rIns="0"/>
-          <a:lstStyle/>
-          <a:p>
-            <a:pPr algn="ctr"/>
+          <a:p>
+            <a:pPr>
+              <a:spcBef>
+                <a:spcPts val="400"/>
+              </a:spcBef>
+            </a:pPr>
             <a:r>
-              <a:rPr sz="1600" b="1">
+              <a:rPr sz="1400">
                 <a:solidFill>
-                  <a:srgbClr val="FFFFFF"/>
+                  <a:srgbClr val="334055"/>
                 </a:solidFill>
                 <a:latin typeface="Calibri"/>
               </a:rPr>
-              <a:t>9</a:t>
-            </a:r>
-          </a:p>
-        </p:txBody>
-      </p:sp>
-      <p:sp>
-        <p:nvSpPr>
-          <p:cNvPr id="25" name="TextBox 24"/>
-          <p:cNvSpPr txBox="1"/>
-          <p:nvPr/>
-        </p:nvSpPr>
-        <p:spPr>
-          <a:xfrm>
-            <a:off x="1450000" y="5102500"/>
-            <a:ext cx="10050000" cy="1147500"/>
-          </a:xfrm>
-          <a:prstGeom prst="rect">
-            <a:avLst/>
-          </a:prstGeom>
-          <a:noFill/>
-        </p:spPr>
-        <p:txBody>
-          <a:bodyPr wrap="square" anchor="ctr" lIns="50800" rIns="50800">
-            <a:spAutoFit/>
-          </a:bodyPr>
-          <a:lstStyle/>
-          <a:p>
-            <a:pPr algn="l"/>
-            <a:r>
-              <a:rPr sz="1400" b="0">
-                <a:solidFill>
-                  <a:srgbClr val="1B2430"/>
-                </a:solidFill>
-                <a:latin typeface="Calibri"/>
-              </a:rPr>
-              <a:t>Ko'rsatkichlarni rasmiylashtiraylik. Agar tizim N ta kameradan har biri f kadr/soniya tezlikda ma'lumot olsa va model bitta kadr uchun C FLOP talab qilsa, zarur hisoblash quvvati P = N × f…</a:t>
+              <a:t>Onlayn (real vaqt) rejimda har bir so'rov alohida va kechikish muhim; paketli (batch) rejimda so'rovlar to'planib, o'tkazuvchanlik muhim; oqimli (streaming) rejimda uzluksiz ma'lumot oqimi qayta ishlanadi.</a:t>
             </a:r>
           </a:p>
         </p:txBody>
@@ -11231,6 +10928,997 @@
         <p:spPr>
           <a:xfrm>
             <a:off x="0" y="0"/>
+            <a:ext cx="12192000" cy="1000000"/>
+          </a:xfrm>
+          <a:prstGeom prst="rect">
+            <a:avLst/>
+          </a:prstGeom>
+          <a:gradFill rotWithShape="1">
+            <a:gsLst>
+              <a:gs pos="0">
+                <a:srgbClr val="1F3A5F"/>
+              </a:gs>
+              <a:gs pos="100000">
+                <a:srgbClr val="2D5C8F"/>
+              </a:gs>
+            </a:gsLst>
+            <a:lin scaled="0" ang="0"/>
+          </a:gradFill>
+          <a:ln>
+            <a:noFill/>
+          </a:ln>
+          <a:effectLst/>
+        </p:spPr>
+        <p:style>
+          <a:lnRef idx="1">
+            <a:schemeClr val="accent1"/>
+          </a:lnRef>
+          <a:fillRef idx="3">
+            <a:schemeClr val="accent1"/>
+          </a:fillRef>
+          <a:effectRef idx="2">
+            <a:schemeClr val="accent1"/>
+          </a:effectRef>
+          <a:fontRef idx="minor">
+            <a:schemeClr val="lt1"/>
+          </a:fontRef>
+        </p:style>
+        <p:txBody>
+          <a:bodyPr rtlCol="0" anchor="ctr"/>
+          <a:lstStyle/>
+          <a:p>
+            <a:pPr algn="ctr"/>
+          </a:p>
+        </p:txBody>
+      </p:sp>
+      <p:sp>
+        <p:nvSpPr>
+          <p:cNvPr id="3" name="Oval 2"/>
+          <p:cNvSpPr/>
+          <p:nvPr/>
+        </p:nvSpPr>
+        <p:spPr>
+          <a:xfrm>
+            <a:off x="11050000" y="-350000"/>
+            <a:ext cx="900000" cy="900000"/>
+          </a:xfrm>
+          <a:prstGeom prst="ellipse">
+            <a:avLst/>
+          </a:prstGeom>
+          <a:solidFill>
+            <a:srgbClr val="3B6EA5"/>
+          </a:solidFill>
+          <a:ln>
+            <a:noFill/>
+          </a:ln>
+          <a:effectLst/>
+        </p:spPr>
+        <p:style>
+          <a:lnRef idx="1">
+            <a:schemeClr val="accent1"/>
+          </a:lnRef>
+          <a:fillRef idx="3">
+            <a:schemeClr val="accent1"/>
+          </a:fillRef>
+          <a:effectRef idx="2">
+            <a:schemeClr val="accent1"/>
+          </a:effectRef>
+          <a:fontRef idx="minor">
+            <a:schemeClr val="lt1"/>
+          </a:fontRef>
+        </p:style>
+        <p:txBody>
+          <a:bodyPr rtlCol="0" anchor="ctr"/>
+          <a:lstStyle/>
+          <a:p>
+            <a:pPr algn="ctr"/>
+          </a:p>
+        </p:txBody>
+      </p:sp>
+      <p:sp>
+        <p:nvSpPr>
+          <p:cNvPr id="4" name="Oval 3"/>
+          <p:cNvSpPr/>
+          <p:nvPr/>
+        </p:nvSpPr>
+        <p:spPr>
+          <a:xfrm>
+            <a:off x="11550000" y="450000"/>
+            <a:ext cx="420000" cy="420000"/>
+          </a:xfrm>
+          <a:prstGeom prst="ellipse">
+            <a:avLst/>
+          </a:prstGeom>
+          <a:solidFill>
+            <a:srgbClr val="0F8B8D"/>
+          </a:solidFill>
+          <a:ln>
+            <a:noFill/>
+          </a:ln>
+          <a:effectLst/>
+        </p:spPr>
+        <p:style>
+          <a:lnRef idx="1">
+            <a:schemeClr val="accent1"/>
+          </a:lnRef>
+          <a:fillRef idx="3">
+            <a:schemeClr val="accent1"/>
+          </a:fillRef>
+          <a:effectRef idx="2">
+            <a:schemeClr val="accent1"/>
+          </a:effectRef>
+          <a:fontRef idx="minor">
+            <a:schemeClr val="lt1"/>
+          </a:fontRef>
+        </p:style>
+        <p:txBody>
+          <a:bodyPr rtlCol="0" anchor="ctr"/>
+          <a:lstStyle/>
+          <a:p>
+            <a:pPr algn="ctr"/>
+          </a:p>
+        </p:txBody>
+      </p:sp>
+      <p:sp>
+        <p:nvSpPr>
+          <p:cNvPr id="5" name="TextBox 4"/>
+          <p:cNvSpPr txBox="1"/>
+          <p:nvPr/>
+        </p:nvSpPr>
+        <p:spPr>
+          <a:xfrm>
+            <a:off x="500000" y="110000"/>
+            <a:ext cx="10300000" cy="300000"/>
+          </a:xfrm>
+          <a:prstGeom prst="rect">
+            <a:avLst/>
+          </a:prstGeom>
+          <a:noFill/>
+        </p:spPr>
+        <p:txBody>
+          <a:bodyPr wrap="square" anchor="t" lIns="50800" rIns="50800">
+            <a:spAutoFit/>
+          </a:bodyPr>
+          <a:lstStyle/>
+          <a:p>
+            <a:pPr algn="l"/>
+            <a:r>
+              <a:rPr sz="1200" b="1">
+                <a:solidFill>
+                  <a:srgbClr val="A9C4E6"/>
+                </a:solidFill>
+                <a:latin typeface="Calibri"/>
+              </a:rPr>
+              <a:t>3-REJA</a:t>
+            </a:r>
+          </a:p>
+        </p:txBody>
+      </p:sp>
+      <p:sp>
+        <p:nvSpPr>
+          <p:cNvPr id="6" name="TextBox 5"/>
+          <p:cNvSpPr txBox="1"/>
+          <p:nvPr/>
+        </p:nvSpPr>
+        <p:spPr>
+          <a:xfrm>
+            <a:off x="500000" y="330000"/>
+            <a:ext cx="10400000" cy="650000"/>
+          </a:xfrm>
+          <a:prstGeom prst="rect">
+            <a:avLst/>
+          </a:prstGeom>
+          <a:noFill/>
+        </p:spPr>
+        <p:txBody>
+          <a:bodyPr wrap="square" anchor="ctr" lIns="50800" rIns="50800">
+            <a:spAutoFit/>
+          </a:bodyPr>
+          <a:lstStyle/>
+          <a:p>
+            <a:pPr algn="l"/>
+            <a:r>
+              <a:rPr sz="2600" b="1">
+                <a:solidFill>
+                  <a:srgbClr val="FFFFFF"/>
+                </a:solidFill>
+                <a:latin typeface="Calibri"/>
+              </a:rPr>
+              <a:t>AI-enabled computer systems arxitekturasi</a:t>
+            </a:r>
+          </a:p>
+        </p:txBody>
+      </p:sp>
+      <p:sp>
+        <p:nvSpPr>
+          <p:cNvPr id="7" name="Rectangle 6"/>
+          <p:cNvSpPr/>
+          <p:nvPr/>
+        </p:nvSpPr>
+        <p:spPr>
+          <a:xfrm>
+            <a:off x="0" y="1000000"/>
+            <a:ext cx="12192000" cy="45000"/>
+          </a:xfrm>
+          <a:prstGeom prst="rect">
+            <a:avLst/>
+          </a:prstGeom>
+          <a:solidFill>
+            <a:srgbClr val="0F8B8D"/>
+          </a:solidFill>
+          <a:ln>
+            <a:noFill/>
+          </a:ln>
+          <a:effectLst/>
+        </p:spPr>
+        <p:style>
+          <a:lnRef idx="1">
+            <a:schemeClr val="accent1"/>
+          </a:lnRef>
+          <a:fillRef idx="3">
+            <a:schemeClr val="accent1"/>
+          </a:fillRef>
+          <a:effectRef idx="2">
+            <a:schemeClr val="accent1"/>
+          </a:effectRef>
+          <a:fontRef idx="minor">
+            <a:schemeClr val="lt1"/>
+          </a:fontRef>
+        </p:style>
+        <p:txBody>
+          <a:bodyPr rtlCol="0" anchor="ctr"/>
+          <a:lstStyle/>
+          <a:p>
+            <a:pPr algn="ctr"/>
+          </a:p>
+        </p:txBody>
+      </p:sp>
+      <p:sp>
+        <p:nvSpPr>
+          <p:cNvPr id="8" name="TextBox 7"/>
+          <p:cNvSpPr txBox="1"/>
+          <p:nvPr/>
+        </p:nvSpPr>
+        <p:spPr>
+          <a:xfrm>
+            <a:off x="500000" y="6420000"/>
+            <a:ext cx="9500000" cy="300000"/>
+          </a:xfrm>
+          <a:prstGeom prst="rect">
+            <a:avLst/>
+          </a:prstGeom>
+          <a:noFill/>
+        </p:spPr>
+        <p:txBody>
+          <a:bodyPr wrap="square" anchor="t" lIns="50800" rIns="50800">
+            <a:spAutoFit/>
+          </a:bodyPr>
+          <a:lstStyle/>
+          <a:p>
+            <a:pPr algn="l"/>
+            <a:r>
+              <a:rPr sz="1000" b="0">
+                <a:solidFill>
+                  <a:srgbClr val="5B6878"/>
+                </a:solidFill>
+                <a:latin typeface="Calibri"/>
+              </a:rPr>
+              <a:t>M1 · Sun'iy intellektga asoslangan kompyuter tizimlari injiniringi: arxitektura va loyihalash tamoyillari</a:t>
+            </a:r>
+          </a:p>
+        </p:txBody>
+      </p:sp>
+      <p:sp>
+        <p:nvSpPr>
+          <p:cNvPr id="9" name="TextBox 8"/>
+          <p:cNvSpPr txBox="1"/>
+          <p:nvPr/>
+        </p:nvSpPr>
+        <p:spPr>
+          <a:xfrm>
+            <a:off x="10600000" y="6420000"/>
+            <a:ext cx="1100000" cy="300000"/>
+          </a:xfrm>
+          <a:prstGeom prst="rect">
+            <a:avLst/>
+          </a:prstGeom>
+          <a:noFill/>
+        </p:spPr>
+        <p:txBody>
+          <a:bodyPr wrap="square" anchor="t" lIns="50800" rIns="50800">
+            <a:spAutoFit/>
+          </a:bodyPr>
+          <a:lstStyle/>
+          <a:p>
+            <a:pPr algn="r"/>
+            <a:r>
+              <a:rPr sz="1000" b="0">
+                <a:solidFill>
+                  <a:srgbClr val="5B6878"/>
+                </a:solidFill>
+                <a:latin typeface="Calibri"/>
+              </a:rPr>
+              <a:t>12</a:t>
+            </a:r>
+          </a:p>
+        </p:txBody>
+      </p:sp>
+      <p:sp>
+        <p:nvSpPr>
+          <p:cNvPr id="10" name="Rounded Rectangle 9"/>
+          <p:cNvSpPr/>
+          <p:nvPr/>
+        </p:nvSpPr>
+        <p:spPr>
+          <a:xfrm>
+            <a:off x="550000" y="3040024"/>
+            <a:ext cx="11100000" cy="1469952"/>
+          </a:xfrm>
+          <a:prstGeom prst="roundRect">
+            <a:avLst>
+              <a:gd name="adj" fmla="val 8000"/>
+            </a:avLst>
+          </a:prstGeom>
+          <a:solidFill>
+            <a:srgbClr val="F5F8FC"/>
+          </a:solidFill>
+          <a:ln>
+            <a:noFill/>
+          </a:ln>
+          <a:effectLst/>
+        </p:spPr>
+        <p:style>
+          <a:lnRef idx="1">
+            <a:schemeClr val="accent1"/>
+          </a:lnRef>
+          <a:fillRef idx="3">
+            <a:schemeClr val="accent1"/>
+          </a:fillRef>
+          <a:effectRef idx="2">
+            <a:schemeClr val="accent1"/>
+          </a:effectRef>
+          <a:fontRef idx="minor">
+            <a:schemeClr val="lt1"/>
+          </a:fontRef>
+        </p:style>
+        <p:txBody>
+          <a:bodyPr rtlCol="0" anchor="ctr"/>
+          <a:lstStyle/>
+          <a:p>
+            <a:pPr algn="ctr"/>
+          </a:p>
+        </p:txBody>
+      </p:sp>
+      <p:sp>
+        <p:nvSpPr>
+          <p:cNvPr id="11" name="Rectangle 10"/>
+          <p:cNvSpPr/>
+          <p:nvPr/>
+        </p:nvSpPr>
+        <p:spPr>
+          <a:xfrm>
+            <a:off x="550000" y="3040024"/>
+            <a:ext cx="70000" cy="1469952"/>
+          </a:xfrm>
+          <a:prstGeom prst="rect">
+            <a:avLst/>
+          </a:prstGeom>
+          <a:solidFill>
+            <a:srgbClr val="6A3FB5"/>
+          </a:solidFill>
+          <a:ln>
+            <a:noFill/>
+          </a:ln>
+          <a:effectLst/>
+        </p:spPr>
+        <p:style>
+          <a:lnRef idx="1">
+            <a:schemeClr val="accent1"/>
+          </a:lnRef>
+          <a:fillRef idx="3">
+            <a:schemeClr val="accent1"/>
+          </a:fillRef>
+          <a:effectRef idx="2">
+            <a:schemeClr val="accent1"/>
+          </a:effectRef>
+          <a:fontRef idx="minor">
+            <a:schemeClr val="lt1"/>
+          </a:fontRef>
+        </p:style>
+        <p:txBody>
+          <a:bodyPr rtlCol="0" anchor="ctr"/>
+          <a:lstStyle/>
+          <a:p>
+            <a:pPr algn="ctr"/>
+          </a:p>
+        </p:txBody>
+      </p:sp>
+      <p:sp>
+        <p:nvSpPr>
+          <p:cNvPr id="12" name="Oval 11"/>
+          <p:cNvSpPr/>
+          <p:nvPr/>
+        </p:nvSpPr>
+        <p:spPr>
+          <a:xfrm>
+            <a:off x="780000" y="3565000"/>
+            <a:ext cx="420000" cy="420000"/>
+          </a:xfrm>
+          <a:prstGeom prst="ellipse">
+            <a:avLst/>
+          </a:prstGeom>
+          <a:solidFill>
+            <a:srgbClr val="6A3FB5"/>
+          </a:solidFill>
+          <a:ln>
+            <a:noFill/>
+          </a:ln>
+          <a:effectLst/>
+        </p:spPr>
+        <p:style>
+          <a:lnRef idx="1">
+            <a:schemeClr val="accent1"/>
+          </a:lnRef>
+          <a:fillRef idx="3">
+            <a:schemeClr val="accent1"/>
+          </a:fillRef>
+          <a:effectRef idx="2">
+            <a:schemeClr val="accent1"/>
+          </a:effectRef>
+          <a:fontRef idx="minor">
+            <a:schemeClr val="lt1"/>
+          </a:fontRef>
+        </p:style>
+        <p:txBody>
+          <a:bodyPr rtlCol="0" anchor="ctr" lIns="0" rIns="0"/>
+          <a:lstStyle/>
+          <a:p>
+            <a:pPr algn="ctr"/>
+            <a:r>
+              <a:rPr sz="1400" b="1">
+                <a:solidFill>
+                  <a:srgbClr val="FFFFFF"/>
+                </a:solidFill>
+                <a:latin typeface="Calibri"/>
+              </a:rPr>
+              <a:t>9</a:t>
+            </a:r>
+          </a:p>
+        </p:txBody>
+      </p:sp>
+      <p:sp>
+        <p:nvSpPr>
+          <p:cNvPr id="13" name="TextBox 12"/>
+          <p:cNvSpPr txBox="1"/>
+          <p:nvPr/>
+        </p:nvSpPr>
+        <p:spPr>
+          <a:xfrm>
+            <a:off x="1380000" y="3080024"/>
+            <a:ext cx="10150000" cy="1389952"/>
+          </a:xfrm>
+          <a:prstGeom prst="rect">
+            <a:avLst/>
+          </a:prstGeom>
+          <a:noFill/>
+        </p:spPr>
+        <p:txBody>
+          <a:bodyPr wrap="square" anchor="ctr">
+            <a:spAutoFit/>
+          </a:bodyPr>
+          <a:lstStyle/>
+          <a:p>
+            <a:r>
+              <a:rPr sz="1800" b="1">
+                <a:solidFill>
+                  <a:srgbClr val="1F3A5F"/>
+                </a:solidFill>
+                <a:latin typeface="Calibri"/>
+              </a:rPr>
+              <a:t>Ko'rsatkichlarni rasmiylashtiraylik.</a:t>
+            </a:r>
+          </a:p>
+          <a:p>
+            <a:pPr>
+              <a:spcBef>
+                <a:spcPts val="400"/>
+              </a:spcBef>
+            </a:pPr>
+            <a:r>
+              <a:rPr sz="1700">
+                <a:solidFill>
+                  <a:srgbClr val="334055"/>
+                </a:solidFill>
+                <a:latin typeface="Calibri"/>
+              </a:rPr>
+              <a:t>Agar tizim N ta kameradan har biri f kadr/soniya tezlikda ma'lumot olsa va model bitta kadr uchun C FLOP talab qilsa, zarur hisoblash quvvati P = N × f × C / η bo'ladi, bu yerda η — tezlatkichdan real foydalanish koeffitsiyenti (odatda 0,2–0,6).</a:t>
+            </a:r>
+          </a:p>
+        </p:txBody>
+      </p:sp>
+    </p:spTree>
+  </p:cSld>
+  <p:clrMapOvr>
+    <a:masterClrMapping/>
+  </p:clrMapOvr>
+  <p:transition spd="med">
+    <p:fade/>
+  </p:transition>
+  <p:timing>
+    <p:tnLst>
+      <p:par>
+        <p:cTn id="1" dur="indefinite" restart="never" nodeType="tmRoot">
+          <p:childTnLst>
+            <p:seq concurrent="1" nextAc="seek">
+              <p:cTn id="2" dur="indefinite" nodeType="mainSeq">
+                <p:childTnLst>
+                  <p:par>
+                    <p:cTn id="31" fill="hold">
+                      <p:stCondLst>
+                        <p:cond delay="indefinite"/>
+                        <p:cond evt="onBegin" delay="0">
+                          <p:tn val="2"/>
+                        </p:cond>
+                      </p:stCondLst>
+                      <p:childTnLst>
+                        <p:par>
+                          <p:cTn id="3" fill="hold">
+                            <p:stCondLst>
+                              <p:cond delay="0"/>
+                            </p:stCondLst>
+                            <p:childTnLst>
+                              <p:par>
+                                <p:cTn id="4" presetID="10" presetClass="entr" presetSubtype="0" fill="hold" grpId="0" nodeType="withEffect">
+                                  <p:stCondLst>
+                                    <p:cond delay="0"/>
+                                  </p:stCondLst>
+                                  <p:childTnLst>
+                                    <p:set>
+                                      <p:cBhvr>
+                                        <p:cTn id="5" dur="1" fill="hold">
+                                          <p:stCondLst>
+                                            <p:cond delay="0"/>
+                                          </p:stCondLst>
+                                        </p:cTn>
+                                        <p:tgtEl>
+                                          <p:spTgt spid="6"/>
+                                        </p:tgtEl>
+                                        <p:attrNameLst>
+                                          <p:attrName>style.visibility</p:attrName>
+                                        </p:attrNameLst>
+                                      </p:cBhvr>
+                                      <p:to>
+                                        <p:strVal val="visible"/>
+                                      </p:to>
+                                    </p:set>
+                                    <p:animEffect transition="in" filter="fade">
+                                      <p:cBhvr>
+                                        <p:cTn id="6" dur="550"/>
+                                        <p:tgtEl>
+                                          <p:spTgt spid="6"/>
+                                        </p:tgtEl>
+                                      </p:cBhvr>
+                                    </p:animEffect>
+                                  </p:childTnLst>
+                                </p:cTn>
+                              </p:par>
+                            </p:childTnLst>
+                          </p:cTn>
+                        </p:par>
+                        <p:par>
+                          <p:cTn id="7" fill="hold">
+                            <p:stCondLst>
+                              <p:cond delay="220"/>
+                            </p:stCondLst>
+                            <p:childTnLst>
+                              <p:par>
+                                <p:cTn id="8" presetID="42" presetClass="entr" presetSubtype="0" fill="hold" grpId="0" nodeType="afterEffect">
+                                  <p:stCondLst>
+                                    <p:cond delay="0"/>
+                                  </p:stCondLst>
+                                  <p:childTnLst>
+                                    <p:set>
+                                      <p:cBhvr>
+                                        <p:cTn id="9" dur="1" fill="hold">
+                                          <p:stCondLst>
+                                            <p:cond delay="0"/>
+                                          </p:stCondLst>
+                                        </p:cTn>
+                                        <p:tgtEl>
+                                          <p:spTgt spid="10"/>
+                                        </p:tgtEl>
+                                        <p:attrNameLst>
+                                          <p:attrName>style.visibility</p:attrName>
+                                        </p:attrNameLst>
+                                      </p:cBhvr>
+                                      <p:to>
+                                        <p:strVal val="visible"/>
+                                      </p:to>
+                                    </p:set>
+                                    <p:animEffect transition="in" filter="fade">
+                                      <p:cBhvr>
+                                        <p:cTn id="10" dur="550"/>
+                                        <p:tgtEl>
+                                          <p:spTgt spid="10"/>
+                                        </p:tgtEl>
+                                      </p:cBhvr>
+                                    </p:animEffect>
+                                    <p:anim calcmode="lin" valueType="num">
+                                      <p:cBhvr additive="base">
+                                        <p:cTn id="11" dur="550" fill="hold"/>
+                                        <p:tgtEl>
+                                          <p:spTgt spid="10"/>
+                                        </p:tgtEl>
+                                        <p:attrNameLst>
+                                          <p:attrName>ppt_x</p:attrName>
+                                        </p:attrNameLst>
+                                      </p:cBhvr>
+                                      <p:tavLst>
+                                        <p:tav tm="0">
+                                          <p:val>
+                                            <p:strVal val="#ppt_x"/>
+                                          </p:val>
+                                        </p:tav>
+                                        <p:tav tm="100000">
+                                          <p:val>
+                                            <p:strVal val="#ppt_x"/>
+                                          </p:val>
+                                        </p:tav>
+                                      </p:tavLst>
+                                    </p:anim>
+                                    <p:anim calcmode="lin" valueType="num">
+                                      <p:cBhvr additive="base">
+                                        <p:cTn id="12" dur="550" fill="hold"/>
+                                        <p:tgtEl>
+                                          <p:spTgt spid="10"/>
+                                        </p:tgtEl>
+                                        <p:attrNameLst>
+                                          <p:attrName>ppt_y</p:attrName>
+                                        </p:attrNameLst>
+                                      </p:cBhvr>
+                                      <p:tavLst>
+                                        <p:tav tm="0">
+                                          <p:val>
+                                            <p:strVal val="#ppt_y+.08"/>
+                                          </p:val>
+                                        </p:tav>
+                                        <p:tav tm="100000">
+                                          <p:val>
+                                            <p:strVal val="#ppt_y"/>
+                                          </p:val>
+                                        </p:tav>
+                                      </p:tavLst>
+                                    </p:anim>
+                                  </p:childTnLst>
+                                </p:cTn>
+                              </p:par>
+                            </p:childTnLst>
+                          </p:cTn>
+                        </p:par>
+                        <p:par>
+                          <p:cTn id="13" fill="hold">
+                            <p:stCondLst>
+                              <p:cond delay="220"/>
+                            </p:stCondLst>
+                            <p:childTnLst>
+                              <p:par>
+                                <p:cTn id="14" presetID="42" presetClass="entr" presetSubtype="0" fill="hold" grpId="0" nodeType="afterEffect">
+                                  <p:stCondLst>
+                                    <p:cond delay="0"/>
+                                  </p:stCondLst>
+                                  <p:childTnLst>
+                                    <p:set>
+                                      <p:cBhvr>
+                                        <p:cTn id="15" dur="1" fill="hold">
+                                          <p:stCondLst>
+                                            <p:cond delay="0"/>
+                                          </p:stCondLst>
+                                        </p:cTn>
+                                        <p:tgtEl>
+                                          <p:spTgt spid="11"/>
+                                        </p:tgtEl>
+                                        <p:attrNameLst>
+                                          <p:attrName>style.visibility</p:attrName>
+                                        </p:attrNameLst>
+                                      </p:cBhvr>
+                                      <p:to>
+                                        <p:strVal val="visible"/>
+                                      </p:to>
+                                    </p:set>
+                                    <p:animEffect transition="in" filter="fade">
+                                      <p:cBhvr>
+                                        <p:cTn id="16" dur="550"/>
+                                        <p:tgtEl>
+                                          <p:spTgt spid="11"/>
+                                        </p:tgtEl>
+                                      </p:cBhvr>
+                                    </p:animEffect>
+                                    <p:anim calcmode="lin" valueType="num">
+                                      <p:cBhvr additive="base">
+                                        <p:cTn id="17" dur="550" fill="hold"/>
+                                        <p:tgtEl>
+                                          <p:spTgt spid="11"/>
+                                        </p:tgtEl>
+                                        <p:attrNameLst>
+                                          <p:attrName>ppt_x</p:attrName>
+                                        </p:attrNameLst>
+                                      </p:cBhvr>
+                                      <p:tavLst>
+                                        <p:tav tm="0">
+                                          <p:val>
+                                            <p:strVal val="#ppt_x"/>
+                                          </p:val>
+                                        </p:tav>
+                                        <p:tav tm="100000">
+                                          <p:val>
+                                            <p:strVal val="#ppt_x"/>
+                                          </p:val>
+                                        </p:tav>
+                                      </p:tavLst>
+                                    </p:anim>
+                                    <p:anim calcmode="lin" valueType="num">
+                                      <p:cBhvr additive="base">
+                                        <p:cTn id="18" dur="550" fill="hold"/>
+                                        <p:tgtEl>
+                                          <p:spTgt spid="11"/>
+                                        </p:tgtEl>
+                                        <p:attrNameLst>
+                                          <p:attrName>ppt_y</p:attrName>
+                                        </p:attrNameLst>
+                                      </p:cBhvr>
+                                      <p:tavLst>
+                                        <p:tav tm="0">
+                                          <p:val>
+                                            <p:strVal val="#ppt_y+.08"/>
+                                          </p:val>
+                                        </p:tav>
+                                        <p:tav tm="100000">
+                                          <p:val>
+                                            <p:strVal val="#ppt_y"/>
+                                          </p:val>
+                                        </p:tav>
+                                      </p:tavLst>
+                                    </p:anim>
+                                  </p:childTnLst>
+                                </p:cTn>
+                              </p:par>
+                            </p:childTnLst>
+                          </p:cTn>
+                        </p:par>
+                        <p:par>
+                          <p:cTn id="19" fill="hold">
+                            <p:stCondLst>
+                              <p:cond delay="220"/>
+                            </p:stCondLst>
+                            <p:childTnLst>
+                              <p:par>
+                                <p:cTn id="20" presetID="53" presetClass="entr" presetSubtype="16" fill="hold" grpId="0" nodeType="afterEffect">
+                                  <p:stCondLst>
+                                    <p:cond delay="0"/>
+                                  </p:stCondLst>
+                                  <p:childTnLst>
+                                    <p:set>
+                                      <p:cBhvr>
+                                        <p:cTn id="21" dur="1" fill="hold">
+                                          <p:stCondLst>
+                                            <p:cond delay="0"/>
+                                          </p:stCondLst>
+                                        </p:cTn>
+                                        <p:tgtEl>
+                                          <p:spTgt spid="12"/>
+                                        </p:tgtEl>
+                                        <p:attrNameLst>
+                                          <p:attrName>style.visibility</p:attrName>
+                                        </p:attrNameLst>
+                                      </p:cBhvr>
+                                      <p:to>
+                                        <p:strVal val="visible"/>
+                                      </p:to>
+                                    </p:set>
+                                    <p:animEffect transition="in" filter="fade">
+                                      <p:cBhvr>
+                                        <p:cTn id="22" dur="550"/>
+                                        <p:tgtEl>
+                                          <p:spTgt spid="12"/>
+                                        </p:tgtEl>
+                                      </p:cBhvr>
+                                    </p:animEffect>
+                                    <p:anim calcmode="lin" valueType="num">
+                                      <p:cBhvr additive="base">
+                                        <p:cTn id="23" dur="550" fill="hold"/>
+                                        <p:tgtEl>
+                                          <p:spTgt spid="12"/>
+                                        </p:tgtEl>
+                                        <p:attrNameLst>
+                                          <p:attrName>ppt_w</p:attrName>
+                                        </p:attrNameLst>
+                                      </p:cBhvr>
+                                      <p:tavLst>
+                                        <p:tav tm="0">
+                                          <p:val>
+                                            <p:strVal val="0"/>
+                                          </p:val>
+                                        </p:tav>
+                                        <p:tav tm="100000">
+                                          <p:val>
+                                            <p:strVal val="#ppt_w"/>
+                                          </p:val>
+                                        </p:tav>
+                                      </p:tavLst>
+                                    </p:anim>
+                                    <p:anim calcmode="lin" valueType="num">
+                                      <p:cBhvr additive="base">
+                                        <p:cTn id="24" dur="550" fill="hold"/>
+                                        <p:tgtEl>
+                                          <p:spTgt spid="12"/>
+                                        </p:tgtEl>
+                                        <p:attrNameLst>
+                                          <p:attrName>ppt_h</p:attrName>
+                                        </p:attrNameLst>
+                                      </p:cBhvr>
+                                      <p:tavLst>
+                                        <p:tav tm="0">
+                                          <p:val>
+                                            <p:strVal val="0"/>
+                                          </p:val>
+                                        </p:tav>
+                                        <p:tav tm="100000">
+                                          <p:val>
+                                            <p:strVal val="#ppt_h"/>
+                                          </p:val>
+                                        </p:tav>
+                                      </p:tavLst>
+                                    </p:anim>
+                                  </p:childTnLst>
+                                </p:cTn>
+                              </p:par>
+                            </p:childTnLst>
+                          </p:cTn>
+                        </p:par>
+                        <p:par>
+                          <p:cTn id="25" fill="hold">
+                            <p:stCondLst>
+                              <p:cond delay="220"/>
+                            </p:stCondLst>
+                            <p:childTnLst>
+                              <p:par>
+                                <p:cTn id="26" presetID="42" presetClass="entr" presetSubtype="0" fill="hold" grpId="0" nodeType="afterEffect">
+                                  <p:stCondLst>
+                                    <p:cond delay="0"/>
+                                  </p:stCondLst>
+                                  <p:childTnLst>
+                                    <p:set>
+                                      <p:cBhvr>
+                                        <p:cTn id="27" dur="1" fill="hold">
+                                          <p:stCondLst>
+                                            <p:cond delay="0"/>
+                                          </p:stCondLst>
+                                        </p:cTn>
+                                        <p:tgtEl>
+                                          <p:spTgt spid="13"/>
+                                        </p:tgtEl>
+                                        <p:attrNameLst>
+                                          <p:attrName>style.visibility</p:attrName>
+                                        </p:attrNameLst>
+                                      </p:cBhvr>
+                                      <p:to>
+                                        <p:strVal val="visible"/>
+                                      </p:to>
+                                    </p:set>
+                                    <p:animEffect transition="in" filter="fade">
+                                      <p:cBhvr>
+                                        <p:cTn id="28" dur="550"/>
+                                        <p:tgtEl>
+                                          <p:spTgt spid="13"/>
+                                        </p:tgtEl>
+                                      </p:cBhvr>
+                                    </p:animEffect>
+                                    <p:anim calcmode="lin" valueType="num">
+                                      <p:cBhvr additive="base">
+                                        <p:cTn id="29" dur="550" fill="hold"/>
+                                        <p:tgtEl>
+                                          <p:spTgt spid="13"/>
+                                        </p:tgtEl>
+                                        <p:attrNameLst>
+                                          <p:attrName>ppt_x</p:attrName>
+                                        </p:attrNameLst>
+                                      </p:cBhvr>
+                                      <p:tavLst>
+                                        <p:tav tm="0">
+                                          <p:val>
+                                            <p:strVal val="#ppt_x"/>
+                                          </p:val>
+                                        </p:tav>
+                                        <p:tav tm="100000">
+                                          <p:val>
+                                            <p:strVal val="#ppt_x"/>
+                                          </p:val>
+                                        </p:tav>
+                                      </p:tavLst>
+                                    </p:anim>
+                                    <p:anim calcmode="lin" valueType="num">
+                                      <p:cBhvr additive="base">
+                                        <p:cTn id="30" dur="550" fill="hold"/>
+                                        <p:tgtEl>
+                                          <p:spTgt spid="13"/>
+                                        </p:tgtEl>
+                                        <p:attrNameLst>
+                                          <p:attrName>ppt_y</p:attrName>
+                                        </p:attrNameLst>
+                                      </p:cBhvr>
+                                      <p:tavLst>
+                                        <p:tav tm="0">
+                                          <p:val>
+                                            <p:strVal val="#ppt_y+.08"/>
+                                          </p:val>
+                                        </p:tav>
+                                        <p:tav tm="100000">
+                                          <p:val>
+                                            <p:strVal val="#ppt_y"/>
+                                          </p:val>
+                                        </p:tav>
+                                      </p:tavLst>
+                                    </p:anim>
+                                  </p:childTnLst>
+                                </p:cTn>
+                              </p:par>
+                            </p:childTnLst>
+                          </p:cTn>
+                        </p:par>
+                      </p:childTnLst>
+                    </p:cTn>
+                  </p:par>
+                </p:childTnLst>
+              </p:cTn>
+              <p:prevCondLst>
+                <p:cond evt="onPrev" delay="0">
+                  <p:tgtEl>
+                    <p:sldTgt/>
+                  </p:tgtEl>
+                </p:cond>
+              </p:prevCondLst>
+              <p:nextCondLst>
+                <p:cond evt="onNext" delay="0">
+                  <p:tgtEl>
+                    <p:sldTgt/>
+                  </p:tgtEl>
+                </p:cond>
+              </p:nextCondLst>
+            </p:seq>
+          </p:childTnLst>
+        </p:cTn>
+      </p:par>
+    </p:tnLst>
+    <p:bldLst>
+      <p:bldP spid="6" grpId="0" animBg="1"/>
+      <p:bldP spid="10" grpId="0" animBg="1"/>
+      <p:bldP spid="11" grpId="0" animBg="1"/>
+      <p:bldP spid="12" grpId="0" animBg="1"/>
+      <p:bldP spid="13" grpId="0" animBg="1"/>
+    </p:bldLst>
+  </p:timing>
+</p:sld>
+</file>
+
+<file path=ppt/slides/slide13.xml><?xml version="1.0" encoding="utf-8"?>
+<p:sld xmlns:a="http://schemas.openxmlformats.org/drawingml/2006/main" xmlns:p="http://schemas.openxmlformats.org/presentationml/2006/main" xmlns:r="http://schemas.openxmlformats.org/officeDocument/2006/relationships">
+  <p:cSld>
+    <p:spTree>
+      <p:nvGrpSpPr>
+        <p:cNvPr id="1" name=""/>
+        <p:cNvGrpSpPr/>
+        <p:nvPr/>
+      </p:nvGrpSpPr>
+      <p:grpSpPr/>
+      <p:sp>
+        <p:nvSpPr>
+          <p:cNvPr id="2" name="Rectangle 1"/>
+          <p:cNvSpPr/>
+          <p:nvPr/>
+        </p:nvSpPr>
+        <p:spPr>
+          <a:xfrm>
+            <a:off x="0" y="0"/>
             <a:ext cx="12192000" cy="6858000"/>
           </a:xfrm>
           <a:prstGeom prst="rect">
@@ -12124,7 +12812,7 @@
 </p:sld>
 </file>
 
-<file path=ppt/slides/slide13.xml><?xml version="1.0" encoding="utf-8"?>
+<file path=ppt/slides/slide14.xml><?xml version="1.0" encoding="utf-8"?>
 <p:sld xmlns:a="http://schemas.openxmlformats.org/drawingml/2006/main" xmlns:p="http://schemas.openxmlformats.org/presentationml/2006/main" xmlns:r="http://schemas.openxmlformats.org/officeDocument/2006/relationships">
   <p:cSld>
     <p:spTree>
@@ -12453,7 +13141,7 @@
                 </a:solidFill>
                 <a:latin typeface="Calibri"/>
               </a:rPr>
-              <a:t>13</a:t>
+              <a:t>14</a:t>
             </a:r>
           </a:p>
         </p:txBody>
@@ -12466,12 +13154,12 @@
         </p:nvSpPr>
         <p:spPr>
           <a:xfrm>
-            <a:off x="550000" y="1300000"/>
-            <a:ext cx="11100000" cy="1147500"/>
+            <a:off x="550000" y="1250000"/>
+            <a:ext cx="11100000" cy="1180000"/>
           </a:xfrm>
           <a:prstGeom prst="roundRect">
             <a:avLst>
-              <a:gd name="adj" fmla="val 18000"/>
+              <a:gd name="adj" fmla="val 8000"/>
             </a:avLst>
           </a:prstGeom>
           <a:solidFill>
@@ -12512,8 +13200,8 @@
         </p:nvSpPr>
         <p:spPr>
           <a:xfrm>
-            <a:off x="550000" y="1300000"/>
-            <a:ext cx="70000" cy="1147500"/>
+            <a:off x="550000" y="1250000"/>
+            <a:ext cx="70000" cy="1180000"/>
           </a:xfrm>
           <a:prstGeom prst="rect">
             <a:avLst/>
@@ -12556,8 +13244,8 @@
         </p:nvSpPr>
         <p:spPr>
           <a:xfrm>
-            <a:off x="800000" y="1643750"/>
-            <a:ext cx="460000" cy="460000"/>
+            <a:off x="780000" y="1630000"/>
+            <a:ext cx="420000" cy="420000"/>
           </a:xfrm>
           <a:prstGeom prst="ellipse">
             <a:avLst/>
@@ -12590,7 +13278,7 @@
           <a:p>
             <a:pPr algn="ctr"/>
             <a:r>
-              <a:rPr sz="1600" b="1">
+              <a:rPr sz="1400" b="1">
                 <a:solidFill>
                   <a:srgbClr val="FFFFFF"/>
                 </a:solidFill>
@@ -12609,8 +13297,8 @@
         </p:nvSpPr>
         <p:spPr>
           <a:xfrm>
-            <a:off x="1450000" y="1300000"/>
-            <a:ext cx="10050000" cy="1147500"/>
+            <a:off x="1380000" y="1290000"/>
+            <a:ext cx="10150000" cy="1100000"/>
           </a:xfrm>
           <a:prstGeom prst="rect">
             <a:avLst/>
@@ -12618,22 +13306,37 @@
           <a:noFill/>
         </p:spPr>
         <p:txBody>
-          <a:bodyPr wrap="square" anchor="ctr" lIns="50800" rIns="50800">
+          <a:bodyPr wrap="square" anchor="ctr">
             <a:spAutoFit/>
           </a:bodyPr>
           <a:lstStyle/>
           <a:p>
-            <a:pPr algn="l"/>
             <a:r>
-              <a:rPr sz="1600" b="0">
+              <a:rPr sz="1500" b="1">
                 <a:solidFill>
-                  <a:srgbClr val="1B2430"/>
+                  <a:srgbClr val="1F3A5F"/>
                 </a:solidFill>
                 <a:latin typeface="Calibri"/>
               </a:rPr>
               <a:t>Hardware–software co-design — tizimning apparat va dasturiy qismlarini alohida emas, balki bir vaqtning o'zida, bir-biriga moslashtirib loyihalash metodologiyasi.</a:t>
             </a:r>
           </a:p>
+          <a:p>
+            <a:pPr>
+              <a:spcBef>
+                <a:spcPts val="400"/>
+              </a:spcBef>
+            </a:pPr>
+            <a:r>
+              <a:rPr sz="1400">
+                <a:solidFill>
+                  <a:srgbClr val="334055"/>
+                </a:solidFill>
+                <a:latin typeface="Calibri"/>
+              </a:rPr>
+              <a:t>An'anaviy yondashuvda apparat avval tanlanadi (yoki mavjud bo'ladi), so'ng dastur unga moslashtiriladi.</a:t>
+            </a:r>
+          </a:p>
         </p:txBody>
       </p:sp>
       <p:sp>
@@ -12644,12 +13347,12 @@
         </p:nvSpPr>
         <p:spPr>
           <a:xfrm>
-            <a:off x="550000" y="2567500"/>
-            <a:ext cx="11100000" cy="1147500"/>
+            <a:off x="550000" y="2540000"/>
+            <a:ext cx="11100000" cy="1180000"/>
           </a:xfrm>
           <a:prstGeom prst="roundRect">
             <a:avLst>
-              <a:gd name="adj" fmla="val 18000"/>
+              <a:gd name="adj" fmla="val 8000"/>
             </a:avLst>
           </a:prstGeom>
           <a:solidFill>
@@ -12690,8 +13393,8 @@
         </p:nvSpPr>
         <p:spPr>
           <a:xfrm>
-            <a:off x="550000" y="2567500"/>
-            <a:ext cx="70000" cy="1147500"/>
+            <a:off x="550000" y="2540000"/>
+            <a:ext cx="70000" cy="1180000"/>
           </a:xfrm>
           <a:prstGeom prst="rect">
             <a:avLst/>
@@ -12734,8 +13437,8 @@
         </p:nvSpPr>
         <p:spPr>
           <a:xfrm>
-            <a:off x="800000" y="2911250"/>
-            <a:ext cx="460000" cy="460000"/>
+            <a:off x="780000" y="2920000"/>
+            <a:ext cx="420000" cy="420000"/>
           </a:xfrm>
           <a:prstGeom prst="ellipse">
             <a:avLst/>
@@ -12768,7 +13471,7 @@
           <a:p>
             <a:pPr algn="ctr"/>
             <a:r>
-              <a:rPr sz="1600" b="1">
+              <a:rPr sz="1400" b="1">
                 <a:solidFill>
                   <a:srgbClr val="FFFFFF"/>
                 </a:solidFill>
@@ -12787,8 +13490,8 @@
         </p:nvSpPr>
         <p:spPr>
           <a:xfrm>
-            <a:off x="1450000" y="2567500"/>
-            <a:ext cx="10050000" cy="1147500"/>
+            <a:off x="1380000" y="2580000"/>
+            <a:ext cx="10150000" cy="1100000"/>
           </a:xfrm>
           <a:prstGeom prst="rect">
             <a:avLst/>
@@ -12796,14 +13499,13 @@
           <a:noFill/>
         </p:spPr>
         <p:txBody>
-          <a:bodyPr wrap="square" anchor="ctr" lIns="50800" rIns="50800">
+          <a:bodyPr wrap="square" anchor="ctr">
             <a:spAutoFit/>
           </a:bodyPr>
           <a:lstStyle/>
           <a:p>
-            <a:pPr algn="l"/>
             <a:r>
-              <a:rPr sz="1600" b="0">
+              <a:rPr sz="1400" b="0">
                 <a:solidFill>
                   <a:srgbClr val="1B2430"/>
                 </a:solidFill>
@@ -12822,12 +13524,12 @@
         </p:nvSpPr>
         <p:spPr>
           <a:xfrm>
-            <a:off x="550000" y="3835000"/>
-            <a:ext cx="11100000" cy="1147500"/>
+            <a:off x="550000" y="3830000"/>
+            <a:ext cx="11100000" cy="1180000"/>
           </a:xfrm>
           <a:prstGeom prst="roundRect">
             <a:avLst>
-              <a:gd name="adj" fmla="val 18000"/>
+              <a:gd name="adj" fmla="val 8000"/>
             </a:avLst>
           </a:prstGeom>
           <a:solidFill>
@@ -12868,8 +13570,8 @@
         </p:nvSpPr>
         <p:spPr>
           <a:xfrm>
-            <a:off x="550000" y="3835000"/>
-            <a:ext cx="70000" cy="1147500"/>
+            <a:off x="550000" y="3830000"/>
+            <a:ext cx="70000" cy="1180000"/>
           </a:xfrm>
           <a:prstGeom prst="rect">
             <a:avLst/>
@@ -12912,8 +13614,8 @@
         </p:nvSpPr>
         <p:spPr>
           <a:xfrm>
-            <a:off x="800000" y="4178750"/>
-            <a:ext cx="460000" cy="460000"/>
+            <a:off x="780000" y="4210000"/>
+            <a:ext cx="420000" cy="420000"/>
           </a:xfrm>
           <a:prstGeom prst="ellipse">
             <a:avLst/>
@@ -12946,7 +13648,7 @@
           <a:p>
             <a:pPr algn="ctr"/>
             <a:r>
-              <a:rPr sz="1600" b="1">
+              <a:rPr sz="1400" b="1">
                 <a:solidFill>
                   <a:srgbClr val="FFFFFF"/>
                 </a:solidFill>
@@ -12965,8 +13667,8 @@
         </p:nvSpPr>
         <p:spPr>
           <a:xfrm>
-            <a:off x="1450000" y="3835000"/>
-            <a:ext cx="10050000" cy="1147500"/>
+            <a:off x="1380000" y="3870000"/>
+            <a:ext cx="10150000" cy="1100000"/>
           </a:xfrm>
           <a:prstGeom prst="rect">
             <a:avLst/>
@@ -12974,22 +13676,37 @@
           <a:noFill/>
         </p:spPr>
         <p:txBody>
-          <a:bodyPr wrap="square" anchor="ctr" lIns="50800" rIns="50800">
+          <a:bodyPr wrap="square" anchor="ctr">
             <a:spAutoFit/>
           </a:bodyPr>
           <a:lstStyle/>
           <a:p>
-            <a:pPr algn="l"/>
             <a:r>
-              <a:rPr sz="1600" b="0">
+              <a:rPr sz="1500" b="1">
                 <a:solidFill>
-                  <a:srgbClr val="1B2430"/>
+                  <a:srgbClr val="1F3A5F"/>
                 </a:solidFill>
                 <a:latin typeface="Calibri"/>
               </a:rPr>
               <a:t>Co-design amaliy jihatdan iterativ jarayon.</a:t>
             </a:r>
           </a:p>
+          <a:p>
+            <a:pPr>
+              <a:spcBef>
+                <a:spcPts val="400"/>
+              </a:spcBef>
+            </a:pPr>
+            <a:r>
+              <a:rPr sz="1400">
+                <a:solidFill>
+                  <a:srgbClr val="334055"/>
+                </a:solidFill>
+                <a:latin typeface="Calibri"/>
+              </a:rPr>
+              <a:t>Birinchi iteratsiyada talab (kechikish, aniqlik, byudjet, energiya) qo'yiladi va nomzod model hamda nomzod apparat tanlanadi. Ikkinchi iteratsiyada model shu apparatda profillanadi — qaysi qatlamlar sekin, xotira yetarlimi, tezlatkichdan foydalanish qanday.</a:t>
+            </a:r>
+          </a:p>
         </p:txBody>
       </p:sp>
       <p:sp>
@@ -13000,12 +13717,12 @@
         </p:nvSpPr>
         <p:spPr>
           <a:xfrm>
-            <a:off x="550000" y="5102500"/>
-            <a:ext cx="11100000" cy="1147500"/>
+            <a:off x="550000" y="5120000"/>
+            <a:ext cx="11100000" cy="1180000"/>
           </a:xfrm>
           <a:prstGeom prst="roundRect">
             <a:avLst>
-              <a:gd name="adj" fmla="val 18000"/>
+              <a:gd name="adj" fmla="val 8000"/>
             </a:avLst>
           </a:prstGeom>
           <a:solidFill>
@@ -13046,8 +13763,8 @@
         </p:nvSpPr>
         <p:spPr>
           <a:xfrm>
-            <a:off x="550000" y="5102500"/>
-            <a:ext cx="70000" cy="1147500"/>
+            <a:off x="550000" y="5120000"/>
+            <a:ext cx="70000" cy="1180000"/>
           </a:xfrm>
           <a:prstGeom prst="rect">
             <a:avLst/>
@@ -13090,8 +13807,8 @@
         </p:nvSpPr>
         <p:spPr>
           <a:xfrm>
-            <a:off x="800000" y="5446250"/>
-            <a:ext cx="460000" cy="460000"/>
+            <a:off x="780000" y="5500000"/>
+            <a:ext cx="420000" cy="420000"/>
           </a:xfrm>
           <a:prstGeom prst="ellipse">
             <a:avLst/>
@@ -13124,7 +13841,7 @@
           <a:p>
             <a:pPr algn="ctr"/>
             <a:r>
-              <a:rPr sz="1600" b="1">
+              <a:rPr sz="1400" b="1">
                 <a:solidFill>
                   <a:srgbClr val="FFFFFF"/>
                 </a:solidFill>
@@ -13143,8 +13860,8 @@
         </p:nvSpPr>
         <p:spPr>
           <a:xfrm>
-            <a:off x="1450000" y="5102500"/>
-            <a:ext cx="10050000" cy="1147500"/>
+            <a:off x="1380000" y="5160000"/>
+            <a:ext cx="10150000" cy="1100000"/>
           </a:xfrm>
           <a:prstGeom prst="rect">
             <a:avLst/>
@@ -13152,20 +13869,35 @@
           <a:noFill/>
         </p:spPr>
         <p:txBody>
-          <a:bodyPr wrap="square" anchor="ctr" lIns="50800" rIns="50800">
+          <a:bodyPr wrap="square" anchor="ctr">
             <a:spAutoFit/>
           </a:bodyPr>
           <a:lstStyle/>
           <a:p>
-            <a:pPr algn="l"/>
             <a:r>
-              <a:rPr sz="1600" b="0">
+              <a:rPr sz="1500" b="1">
                 <a:solidFill>
-                  <a:srgbClr val="1B2430"/>
+                  <a:srgbClr val="1F3A5F"/>
                 </a:solidFill>
                 <a:latin typeface="Calibri"/>
               </a:rPr>
               <a:t>Co-design kontekstida ikki klassik qonun doimo yodda bo'lishi kerak.</a:t>
+            </a:r>
+          </a:p>
+          <a:p>
+            <a:pPr>
+              <a:spcBef>
+                <a:spcPts val="400"/>
+              </a:spcBef>
+            </a:pPr>
+            <a:r>
+              <a:rPr sz="1400">
+                <a:solidFill>
+                  <a:srgbClr val="334055"/>
+                </a:solidFill>
+                <a:latin typeface="Calibri"/>
+              </a:rPr>
+              <a:t>Amdal qonuni (Amdahl's law): agar dasturning p ulushi tezlashtirilsa va qolgan 1−p ulushi o'zgarmasa, umumiy tezlashuv S = 1 / ((1−p) + p/s) dan oshmaydi, bu yerda s — tezlashtirilgan qismning tezlashuvi.</a:t>
             </a:r>
           </a:p>
         </p:txBody>
@@ -14726,7 +15458,7 @@
 </p:sld>
 </file>
 
-<file path=ppt/slides/slide14.xml><?xml version="1.0" encoding="utf-8"?>
+<file path=ppt/slides/slide15.xml><?xml version="1.0" encoding="utf-8"?>
 <p:sld xmlns:a="http://schemas.openxmlformats.org/drawingml/2006/main" xmlns:p="http://schemas.openxmlformats.org/presentationml/2006/main" xmlns:r="http://schemas.openxmlformats.org/officeDocument/2006/relationships">
   <p:cSld>
     <p:spTree>
@@ -15055,7 +15787,7 @@
                 </a:solidFill>
                 <a:latin typeface="Calibri"/>
               </a:rPr>
-              <a:t>14</a:t>
+              <a:t>15</a:t>
             </a:r>
           </a:p>
         </p:txBody>
@@ -15682,7 +16414,7 @@
 </p:sld>
 </file>
 
-<file path=ppt/slides/slide15.xml><?xml version="1.0" encoding="utf-8"?>
+<file path=ppt/slides/slide16.xml><?xml version="1.0" encoding="utf-8"?>
 <p:sld xmlns:a="http://schemas.openxmlformats.org/drawingml/2006/main" xmlns:p="http://schemas.openxmlformats.org/presentationml/2006/main" xmlns:r="http://schemas.openxmlformats.org/officeDocument/2006/relationships">
   <p:cSld>
     <p:spTree>
@@ -16594,7 +17326,7 @@
 </p:sld>
 </file>
 
-<file path=ppt/slides/slide16.xml><?xml version="1.0" encoding="utf-8"?>
+<file path=ppt/slides/slide17.xml><?xml version="1.0" encoding="utf-8"?>
 <p:sld xmlns:a="http://schemas.openxmlformats.org/drawingml/2006/main" xmlns:p="http://schemas.openxmlformats.org/presentationml/2006/main" xmlns:r="http://schemas.openxmlformats.org/officeDocument/2006/relationships">
   <p:cSld>
     <p:spTree>
@@ -16923,7 +17655,7 @@
                 </a:solidFill>
                 <a:latin typeface="Calibri"/>
               </a:rPr>
-              <a:t>16</a:t>
+              <a:t>17</a:t>
             </a:r>
           </a:p>
         </p:txBody>
@@ -16936,12 +17668,12 @@
         </p:nvSpPr>
         <p:spPr>
           <a:xfrm>
-            <a:off x="550000" y="2533333"/>
-            <a:ext cx="11100000" cy="1250000"/>
+            <a:off x="550000" y="2897530"/>
+            <a:ext cx="11100000" cy="1754940"/>
           </a:xfrm>
           <a:prstGeom prst="roundRect">
             <a:avLst>
-              <a:gd name="adj" fmla="val 18000"/>
+              <a:gd name="adj" fmla="val 8000"/>
             </a:avLst>
           </a:prstGeom>
           <a:solidFill>
@@ -16982,8 +17714,8 @@
         </p:nvSpPr>
         <p:spPr>
           <a:xfrm>
-            <a:off x="550000" y="2533333"/>
-            <a:ext cx="70000" cy="1250000"/>
+            <a:off x="550000" y="2897530"/>
+            <a:ext cx="70000" cy="1754940"/>
           </a:xfrm>
           <a:prstGeom prst="rect">
             <a:avLst/>
@@ -17026,8 +17758,8 @@
         </p:nvSpPr>
         <p:spPr>
           <a:xfrm>
-            <a:off x="800000" y="2928333"/>
-            <a:ext cx="460000" cy="460000"/>
+            <a:off x="780000" y="3565000"/>
+            <a:ext cx="420000" cy="420000"/>
           </a:xfrm>
           <a:prstGeom prst="ellipse">
             <a:avLst/>
@@ -17060,7 +17792,7 @@
           <a:p>
             <a:pPr algn="ctr"/>
             <a:r>
-              <a:rPr sz="1600" b="1">
+              <a:rPr sz="1400" b="1">
                 <a:solidFill>
                   <a:srgbClr val="FFFFFF"/>
                 </a:solidFill>
@@ -17079,8 +17811,8 @@
         </p:nvSpPr>
         <p:spPr>
           <a:xfrm>
-            <a:off x="1450000" y="2533333"/>
-            <a:ext cx="10050000" cy="1250000"/>
+            <a:off x="1380000" y="2937530"/>
+            <a:ext cx="10150000" cy="1674940"/>
           </a:xfrm>
           <a:prstGeom prst="rect">
             <a:avLst/>
@@ -17088,20 +17820,35 @@
           <a:noFill/>
         </p:spPr>
         <p:txBody>
-          <a:bodyPr wrap="square" anchor="ctr" lIns="50800" rIns="50800">
+          <a:bodyPr wrap="square" anchor="ctr">
             <a:spAutoFit/>
           </a:bodyPr>
           <a:lstStyle/>
           <a:p>
-            <a:pPr algn="l"/>
             <a:r>
-              <a:rPr sz="1600" b="0">
+              <a:rPr sz="1800" b="1">
                 <a:solidFill>
-                  <a:srgbClr val="1B2430"/>
+                  <a:srgbClr val="1F3A5F"/>
                 </a:solidFill>
                 <a:latin typeface="Calibri"/>
               </a:rPr>
-              <a:t>Yuqoridagi tushunchalar asosida SI tizimini loyihalashning amaliy tamoyillarini shakllantirish mumkin. Talabdan boshlash: kechikish byudjeti (masalan, kadrdan hodisagacha 200 ms), aniqlik chegarasi (mAP yoki F1), yuk (kameralar soni, so'rov/soniya), energiya…</a:t>
+              <a:t>Yuqoridagi tushunchalar asosida SI tizimini loyihalashning amaliy tamoyillarini shakllantirish mumkin.</a:t>
+            </a:r>
+          </a:p>
+          <a:p>
+            <a:pPr>
+              <a:spcBef>
+                <a:spcPts val="400"/>
+              </a:spcBef>
+            </a:pPr>
+            <a:r>
+              <a:rPr sz="1700">
+                <a:solidFill>
+                  <a:srgbClr val="334055"/>
+                </a:solidFill>
+                <a:latin typeface="Calibri"/>
+              </a:rPr>
+              <a:t>Talabdan boshlash: kechikish byudjeti (masalan, kadrdan hodisagacha 200 ms), aniqlik chegarasi (mAP yoki F1), yuk (kameralar soni, so'rov/soniya), energiya va narx cheklovlari raqam bilan yoziladi; raqamsiz talab — talab emas.</a:t>
             </a:r>
           </a:p>
         </p:txBody>
@@ -17570,7 +18317,7 @@
 </p:sld>
 </file>
 
-<file path=ppt/slides/slide17.xml><?xml version="1.0" encoding="utf-8"?>
+<file path=ppt/slides/slide18.xml><?xml version="1.0" encoding="utf-8"?>
 <p:sld xmlns:a="http://schemas.openxmlformats.org/drawingml/2006/main" xmlns:p="http://schemas.openxmlformats.org/presentationml/2006/main" xmlns:r="http://schemas.openxmlformats.org/officeDocument/2006/relationships">
   <p:cSld>
     <p:spTree>
@@ -18496,8 +19243,8 @@
         </p:nvSpPr>
         <p:spPr>
           <a:xfrm>
-            <a:off x="550000" y="1300000"/>
-            <a:ext cx="11100000" cy="894000"/>
+            <a:off x="550000" y="2255000"/>
+            <a:ext cx="11100000" cy="520000"/>
           </a:xfrm>
           <a:prstGeom prst="roundRect">
             <a:avLst>
@@ -18542,8 +19289,8 @@
         </p:nvSpPr>
         <p:spPr>
           <a:xfrm>
-            <a:off x="550000" y="1300000"/>
-            <a:ext cx="70000" cy="894000"/>
+            <a:off x="550000" y="2255000"/>
+            <a:ext cx="70000" cy="520000"/>
           </a:xfrm>
           <a:prstGeom prst="rect">
             <a:avLst/>
@@ -18586,8 +19333,8 @@
         </p:nvSpPr>
         <p:spPr>
           <a:xfrm>
-            <a:off x="800000" y="1517000"/>
-            <a:ext cx="460000" cy="460000"/>
+            <a:off x="780000" y="2325000"/>
+            <a:ext cx="380000" cy="380000"/>
           </a:xfrm>
           <a:prstGeom prst="ellipse">
             <a:avLst/>
@@ -18620,7 +19367,7 @@
           <a:p>
             <a:pPr algn="ctr"/>
             <a:r>
-              <a:rPr sz="1600" b="1">
+              <a:rPr sz="1400" b="1">
                 <a:solidFill>
                   <a:srgbClr val="FFFFFF"/>
                 </a:solidFill>
@@ -18639,8 +19386,8 @@
         </p:nvSpPr>
         <p:spPr>
           <a:xfrm>
-            <a:off x="1450000" y="1300000"/>
-            <a:ext cx="10050000" cy="894000"/>
+            <a:off x="1380000" y="2295000"/>
+            <a:ext cx="10150000" cy="440000"/>
           </a:xfrm>
           <a:prstGeom prst="rect">
             <a:avLst/>
@@ -18648,14 +19395,13 @@
           <a:noFill/>
         </p:spPr>
         <p:txBody>
-          <a:bodyPr wrap="square" anchor="ctr" lIns="50800" rIns="50800">
+          <a:bodyPr wrap="square" anchor="ctr">
             <a:spAutoFit/>
           </a:bodyPr>
           <a:lstStyle/>
           <a:p>
-            <a:pPr algn="l"/>
             <a:r>
-              <a:rPr sz="1900" b="0">
+              <a:rPr sz="1600" b="0">
                 <a:solidFill>
                   <a:srgbClr val="1B2430"/>
                 </a:solidFill>
@@ -18674,8 +19420,8 @@
         </p:nvSpPr>
         <p:spPr>
           <a:xfrm>
-            <a:off x="550000" y="2314000"/>
-            <a:ext cx="11100000" cy="894000"/>
+            <a:off x="550000" y="2885000"/>
+            <a:ext cx="11100000" cy="520000"/>
           </a:xfrm>
           <a:prstGeom prst="roundRect">
             <a:avLst>
@@ -18720,8 +19466,8 @@
         </p:nvSpPr>
         <p:spPr>
           <a:xfrm>
-            <a:off x="550000" y="2314000"/>
-            <a:ext cx="70000" cy="894000"/>
+            <a:off x="550000" y="2885000"/>
+            <a:ext cx="70000" cy="520000"/>
           </a:xfrm>
           <a:prstGeom prst="rect">
             <a:avLst/>
@@ -18764,8 +19510,8 @@
         </p:nvSpPr>
         <p:spPr>
           <a:xfrm>
-            <a:off x="800000" y="2531000"/>
-            <a:ext cx="460000" cy="460000"/>
+            <a:off x="780000" y="2955000"/>
+            <a:ext cx="380000" cy="380000"/>
           </a:xfrm>
           <a:prstGeom prst="ellipse">
             <a:avLst/>
@@ -18798,7 +19544,7 @@
           <a:p>
             <a:pPr algn="ctr"/>
             <a:r>
-              <a:rPr sz="1600" b="1">
+              <a:rPr sz="1400" b="1">
                 <a:solidFill>
                   <a:srgbClr val="FFFFFF"/>
                 </a:solidFill>
@@ -18817,8 +19563,8 @@
         </p:nvSpPr>
         <p:spPr>
           <a:xfrm>
-            <a:off x="1450000" y="2314000"/>
-            <a:ext cx="10050000" cy="894000"/>
+            <a:off x="1380000" y="2925000"/>
+            <a:ext cx="10150000" cy="440000"/>
           </a:xfrm>
           <a:prstGeom prst="rect">
             <a:avLst/>
@@ -18826,14 +19572,13 @@
           <a:noFill/>
         </p:spPr>
         <p:txBody>
-          <a:bodyPr wrap="square" anchor="ctr" lIns="50800" rIns="50800">
+          <a:bodyPr wrap="square" anchor="ctr">
             <a:spAutoFit/>
           </a:bodyPr>
           <a:lstStyle/>
           <a:p>
-            <a:pPr algn="l"/>
             <a:r>
-              <a:rPr sz="1900" b="0">
+              <a:rPr sz="1600" b="0">
                 <a:solidFill>
                   <a:srgbClr val="1B2430"/>
                 </a:solidFill>
@@ -18852,8 +19597,8 @@
         </p:nvSpPr>
         <p:spPr>
           <a:xfrm>
-            <a:off x="550000" y="3328000"/>
-            <a:ext cx="11100000" cy="894000"/>
+            <a:off x="550000" y="3515000"/>
+            <a:ext cx="11100000" cy="520000"/>
           </a:xfrm>
           <a:prstGeom prst="roundRect">
             <a:avLst>
@@ -18898,8 +19643,8 @@
         </p:nvSpPr>
         <p:spPr>
           <a:xfrm>
-            <a:off x="550000" y="3328000"/>
-            <a:ext cx="70000" cy="894000"/>
+            <a:off x="550000" y="3515000"/>
+            <a:ext cx="70000" cy="520000"/>
           </a:xfrm>
           <a:prstGeom prst="rect">
             <a:avLst/>
@@ -18942,8 +19687,8 @@
         </p:nvSpPr>
         <p:spPr>
           <a:xfrm>
-            <a:off x="800000" y="3545000"/>
-            <a:ext cx="460000" cy="460000"/>
+            <a:off x="780000" y="3585000"/>
+            <a:ext cx="380000" cy="380000"/>
           </a:xfrm>
           <a:prstGeom prst="ellipse">
             <a:avLst/>
@@ -18976,7 +19721,7 @@
           <a:p>
             <a:pPr algn="ctr"/>
             <a:r>
-              <a:rPr sz="1600" b="1">
+              <a:rPr sz="1400" b="1">
                 <a:solidFill>
                   <a:srgbClr val="FFFFFF"/>
                 </a:solidFill>
@@ -18995,8 +19740,8 @@
         </p:nvSpPr>
         <p:spPr>
           <a:xfrm>
-            <a:off x="1450000" y="3328000"/>
-            <a:ext cx="10050000" cy="894000"/>
+            <a:off x="1380000" y="3555000"/>
+            <a:ext cx="10150000" cy="440000"/>
           </a:xfrm>
           <a:prstGeom prst="rect">
             <a:avLst/>
@@ -19004,14 +19749,13 @@
           <a:noFill/>
         </p:spPr>
         <p:txBody>
-          <a:bodyPr wrap="square" anchor="ctr" lIns="50800" rIns="50800">
+          <a:bodyPr wrap="square" anchor="ctr">
             <a:spAutoFit/>
           </a:bodyPr>
           <a:lstStyle/>
           <a:p>
-            <a:pPr algn="l"/>
             <a:r>
-              <a:rPr sz="1900" b="0">
+              <a:rPr sz="1600" b="0">
                 <a:solidFill>
                   <a:srgbClr val="1B2430"/>
                 </a:solidFill>
@@ -19030,8 +19774,8 @@
         </p:nvSpPr>
         <p:spPr>
           <a:xfrm>
-            <a:off x="550000" y="4342000"/>
-            <a:ext cx="11100000" cy="894000"/>
+            <a:off x="550000" y="4145000"/>
+            <a:ext cx="11100000" cy="520000"/>
           </a:xfrm>
           <a:prstGeom prst="roundRect">
             <a:avLst>
@@ -19076,8 +19820,8 @@
         </p:nvSpPr>
         <p:spPr>
           <a:xfrm>
-            <a:off x="550000" y="4342000"/>
-            <a:ext cx="70000" cy="894000"/>
+            <a:off x="550000" y="4145000"/>
+            <a:ext cx="70000" cy="520000"/>
           </a:xfrm>
           <a:prstGeom prst="rect">
             <a:avLst/>
@@ -19120,8 +19864,8 @@
         </p:nvSpPr>
         <p:spPr>
           <a:xfrm>
-            <a:off x="800000" y="4559000"/>
-            <a:ext cx="460000" cy="460000"/>
+            <a:off x="780000" y="4215000"/>
+            <a:ext cx="380000" cy="380000"/>
           </a:xfrm>
           <a:prstGeom prst="ellipse">
             <a:avLst/>
@@ -19154,7 +19898,7 @@
           <a:p>
             <a:pPr algn="ctr"/>
             <a:r>
-              <a:rPr sz="1600" b="1">
+              <a:rPr sz="1400" b="1">
                 <a:solidFill>
                   <a:srgbClr val="FFFFFF"/>
                 </a:solidFill>
@@ -19173,8 +19917,8 @@
         </p:nvSpPr>
         <p:spPr>
           <a:xfrm>
-            <a:off x="1450000" y="4342000"/>
-            <a:ext cx="10050000" cy="894000"/>
+            <a:off x="1380000" y="4185000"/>
+            <a:ext cx="10150000" cy="440000"/>
           </a:xfrm>
           <a:prstGeom prst="rect">
             <a:avLst/>
@@ -19182,14 +19926,13 @@
           <a:noFill/>
         </p:spPr>
         <p:txBody>
-          <a:bodyPr wrap="square" anchor="ctr" lIns="50800" rIns="50800">
+          <a:bodyPr wrap="square" anchor="ctr">
             <a:spAutoFit/>
           </a:bodyPr>
           <a:lstStyle/>
           <a:p>
-            <a:pPr algn="l"/>
             <a:r>
-              <a:rPr sz="1900" b="0">
+              <a:rPr sz="1600" b="0">
                 <a:solidFill>
                   <a:srgbClr val="1B2430"/>
                 </a:solidFill>
@@ -19208,8 +19951,8 @@
         </p:nvSpPr>
         <p:spPr>
           <a:xfrm>
-            <a:off x="550000" y="5356000"/>
-            <a:ext cx="11100000" cy="894000"/>
+            <a:off x="550000" y="4775000"/>
+            <a:ext cx="11100000" cy="520000"/>
           </a:xfrm>
           <a:prstGeom prst="roundRect">
             <a:avLst>
@@ -19254,8 +19997,8 @@
         </p:nvSpPr>
         <p:spPr>
           <a:xfrm>
-            <a:off x="550000" y="5356000"/>
-            <a:ext cx="70000" cy="894000"/>
+            <a:off x="550000" y="4775000"/>
+            <a:ext cx="70000" cy="520000"/>
           </a:xfrm>
           <a:prstGeom prst="rect">
             <a:avLst/>
@@ -19298,8 +20041,8 @@
         </p:nvSpPr>
         <p:spPr>
           <a:xfrm>
-            <a:off x="800000" y="5573000"/>
-            <a:ext cx="460000" cy="460000"/>
+            <a:off x="780000" y="4845000"/>
+            <a:ext cx="380000" cy="380000"/>
           </a:xfrm>
           <a:prstGeom prst="ellipse">
             <a:avLst/>
@@ -19332,7 +20075,7 @@
           <a:p>
             <a:pPr algn="ctr"/>
             <a:r>
-              <a:rPr sz="1600" b="1">
+              <a:rPr sz="1400" b="1">
                 <a:solidFill>
                   <a:srgbClr val="FFFFFF"/>
                 </a:solidFill>
@@ -19351,8 +20094,8 @@
         </p:nvSpPr>
         <p:spPr>
           <a:xfrm>
-            <a:off x="1450000" y="5356000"/>
-            <a:ext cx="10050000" cy="894000"/>
+            <a:off x="1380000" y="4815000"/>
+            <a:ext cx="10150000" cy="440000"/>
           </a:xfrm>
           <a:prstGeom prst="rect">
             <a:avLst/>
@@ -19360,14 +20103,13 @@
           <a:noFill/>
         </p:spPr>
         <p:txBody>
-          <a:bodyPr wrap="square" anchor="ctr" lIns="50800" rIns="50800">
+          <a:bodyPr wrap="square" anchor="ctr">
             <a:spAutoFit/>
           </a:bodyPr>
           <a:lstStyle/>
           <a:p>
-            <a:pPr algn="l"/>
             <a:r>
-              <a:rPr sz="1900" b="0">
+              <a:rPr sz="1600" b="0">
                 <a:solidFill>
                   <a:srgbClr val="1B2430"/>
                 </a:solidFill>
@@ -22552,12 +23294,12 @@
         </p:nvSpPr>
         <p:spPr>
           <a:xfrm>
-            <a:off x="550000" y="1300000"/>
-            <a:ext cx="11100000" cy="1147500"/>
+            <a:off x="550000" y="1250000"/>
+            <a:ext cx="11100000" cy="1180000"/>
           </a:xfrm>
           <a:prstGeom prst="roundRect">
             <a:avLst>
-              <a:gd name="adj" fmla="val 18000"/>
+              <a:gd name="adj" fmla="val 8000"/>
             </a:avLst>
           </a:prstGeom>
           <a:solidFill>
@@ -22598,8 +23340,8 @@
         </p:nvSpPr>
         <p:spPr>
           <a:xfrm>
-            <a:off x="550000" y="1300000"/>
-            <a:ext cx="70000" cy="1147500"/>
+            <a:off x="550000" y="1250000"/>
+            <a:ext cx="70000" cy="1180000"/>
           </a:xfrm>
           <a:prstGeom prst="rect">
             <a:avLst/>
@@ -22642,8 +23384,8 @@
         </p:nvSpPr>
         <p:spPr>
           <a:xfrm>
-            <a:off x="800000" y="1643750"/>
-            <a:ext cx="460000" cy="460000"/>
+            <a:off x="780000" y="1630000"/>
+            <a:ext cx="420000" cy="420000"/>
           </a:xfrm>
           <a:prstGeom prst="ellipse">
             <a:avLst/>
@@ -22676,7 +23418,7 @@
           <a:p>
             <a:pPr algn="ctr"/>
             <a:r>
-              <a:rPr sz="1600" b="1">
+              <a:rPr sz="1400" b="1">
                 <a:solidFill>
                   <a:srgbClr val="FFFFFF"/>
                 </a:solidFill>
@@ -22695,8 +23437,8 @@
         </p:nvSpPr>
         <p:spPr>
           <a:xfrm>
-            <a:off x="1450000" y="1300000"/>
-            <a:ext cx="10050000" cy="1147500"/>
+            <a:off x="1380000" y="1290000"/>
+            <a:ext cx="10150000" cy="1100000"/>
           </a:xfrm>
           <a:prstGeom prst="rect">
             <a:avLst/>
@@ -22704,12 +23446,11 @@
           <a:noFill/>
         </p:spPr>
         <p:txBody>
-          <a:bodyPr wrap="square" anchor="ctr" lIns="50800" rIns="50800">
+          <a:bodyPr wrap="square" anchor="ctr">
             <a:spAutoFit/>
           </a:bodyPr>
           <a:lstStyle/>
           <a:p>
-            <a:pPr algn="l"/>
             <a:r>
               <a:rPr sz="1400" b="0">
                 <a:solidFill>
@@ -22717,7 +23458,7 @@
                 </a:solidFill>
                 <a:latin typeface="Calibri"/>
               </a:rPr>
-              <a:t>Sun'iy intellekt injiniringi (AI engineering) — SI komponentlarini o'z ichiga olgan tizimlarni ishonchli, takrorlanuvchi va masshtablanuvchi tarzda loyihalash, qurish, joylashtirish va…</a:t>
+              <a:t>Sun'iy intellekt injiniringi (AI engineering) — SI komponentlarini o'z ichiga olgan tizimlarni ishonchli, takrorlanuvchi va masshtablanuvchi tarzda loyihalash, qurish, joylashtirish va ekspluatatsiya qilish fanidir.</a:t>
             </a:r>
           </a:p>
         </p:txBody>
@@ -22730,12 +23471,12 @@
         </p:nvSpPr>
         <p:spPr>
           <a:xfrm>
-            <a:off x="550000" y="2567500"/>
-            <a:ext cx="11100000" cy="1147500"/>
+            <a:off x="550000" y="2540000"/>
+            <a:ext cx="11100000" cy="1180000"/>
           </a:xfrm>
           <a:prstGeom prst="roundRect">
             <a:avLst>
-              <a:gd name="adj" fmla="val 18000"/>
+              <a:gd name="adj" fmla="val 8000"/>
             </a:avLst>
           </a:prstGeom>
           <a:solidFill>
@@ -22776,8 +23517,8 @@
         </p:nvSpPr>
         <p:spPr>
           <a:xfrm>
-            <a:off x="550000" y="2567500"/>
-            <a:ext cx="70000" cy="1147500"/>
+            <a:off x="550000" y="2540000"/>
+            <a:ext cx="70000" cy="1180000"/>
           </a:xfrm>
           <a:prstGeom prst="rect">
             <a:avLst/>
@@ -22820,8 +23561,8 @@
         </p:nvSpPr>
         <p:spPr>
           <a:xfrm>
-            <a:off x="800000" y="2911250"/>
-            <a:ext cx="460000" cy="460000"/>
+            <a:off x="780000" y="2920000"/>
+            <a:ext cx="420000" cy="420000"/>
           </a:xfrm>
           <a:prstGeom prst="ellipse">
             <a:avLst/>
@@ -22854,7 +23595,7 @@
           <a:p>
             <a:pPr algn="ctr"/>
             <a:r>
-              <a:rPr sz="1600" b="1">
+              <a:rPr sz="1400" b="1">
                 <a:solidFill>
                   <a:srgbClr val="FFFFFF"/>
                 </a:solidFill>
@@ -22873,8 +23614,8 @@
         </p:nvSpPr>
         <p:spPr>
           <a:xfrm>
-            <a:off x="1450000" y="2567500"/>
-            <a:ext cx="10050000" cy="1147500"/>
+            <a:off x="1380000" y="2580000"/>
+            <a:ext cx="10150000" cy="1100000"/>
           </a:xfrm>
           <a:prstGeom prst="rect">
             <a:avLst/>
@@ -22882,22 +23623,37 @@
           <a:noFill/>
         </p:spPr>
         <p:txBody>
-          <a:bodyPr wrap="square" anchor="ctr" lIns="50800" rIns="50800">
+          <a:bodyPr wrap="square" anchor="ctr">
             <a:spAutoFit/>
           </a:bodyPr>
           <a:lstStyle/>
           <a:p>
-            <a:pPr algn="l"/>
             <a:r>
-              <a:rPr sz="1400" b="0">
+              <a:rPr sz="1500" b="1">
                 <a:solidFill>
-                  <a:srgbClr val="1B2430"/>
+                  <a:srgbClr val="1F3A5F"/>
                 </a:solidFill>
                 <a:latin typeface="Calibri"/>
               </a:rPr>
               <a:t>Amershi va hammualliflar SI tizimlarining an'anaviy dasturiy ta'minotdan uchta tub farqini ko'rsatadilar.</a:t>
             </a:r>
           </a:p>
+          <a:p>
+            <a:pPr>
+              <a:spcBef>
+                <a:spcPts val="400"/>
+              </a:spcBef>
+            </a:pPr>
+            <a:r>
+              <a:rPr sz="1400">
+                <a:solidFill>
+                  <a:srgbClr val="334055"/>
+                </a:solidFill>
+                <a:latin typeface="Calibri"/>
+              </a:rPr>
+              <a:t>Birinchidan, ma'lumotni boshqarish koddan ko'ra murakkabroq: ma'lumot versiyalanishi, sifati tekshirilishi, kelib chiqishi (provenance) kuzatilishi kerak.</a:t>
+            </a:r>
+          </a:p>
         </p:txBody>
       </p:sp>
       <p:sp>
@@ -22908,12 +23664,12 @@
         </p:nvSpPr>
         <p:spPr>
           <a:xfrm>
-            <a:off x="550000" y="3835000"/>
-            <a:ext cx="11100000" cy="1147500"/>
+            <a:off x="550000" y="3830000"/>
+            <a:ext cx="11100000" cy="1180000"/>
           </a:xfrm>
           <a:prstGeom prst="roundRect">
             <a:avLst>
-              <a:gd name="adj" fmla="val 18000"/>
+              <a:gd name="adj" fmla="val 8000"/>
             </a:avLst>
           </a:prstGeom>
           <a:solidFill>
@@ -22954,8 +23710,8 @@
         </p:nvSpPr>
         <p:spPr>
           <a:xfrm>
-            <a:off x="550000" y="3835000"/>
-            <a:ext cx="70000" cy="1147500"/>
+            <a:off x="550000" y="3830000"/>
+            <a:ext cx="70000" cy="1180000"/>
           </a:xfrm>
           <a:prstGeom prst="rect">
             <a:avLst/>
@@ -22998,8 +23754,8 @@
         </p:nvSpPr>
         <p:spPr>
           <a:xfrm>
-            <a:off x="800000" y="4178750"/>
-            <a:ext cx="460000" cy="460000"/>
+            <a:off x="780000" y="4210000"/>
+            <a:ext cx="420000" cy="420000"/>
           </a:xfrm>
           <a:prstGeom prst="ellipse">
             <a:avLst/>
@@ -23032,7 +23788,7 @@
           <a:p>
             <a:pPr algn="ctr"/>
             <a:r>
-              <a:rPr sz="1600" b="1">
+              <a:rPr sz="1400" b="1">
                 <a:solidFill>
                   <a:srgbClr val="FFFFFF"/>
                 </a:solidFill>
@@ -23051,8 +23807,8 @@
         </p:nvSpPr>
         <p:spPr>
           <a:xfrm>
-            <a:off x="1450000" y="3835000"/>
-            <a:ext cx="10050000" cy="1147500"/>
+            <a:off x="1380000" y="3870000"/>
+            <a:ext cx="10150000" cy="1100000"/>
           </a:xfrm>
           <a:prstGeom prst="rect">
             <a:avLst/>
@@ -23060,20 +23816,35 @@
           <a:noFill/>
         </p:spPr>
         <p:txBody>
-          <a:bodyPr wrap="square" anchor="ctr" lIns="50800" rIns="50800">
+          <a:bodyPr wrap="square" anchor="ctr">
             <a:spAutoFit/>
           </a:bodyPr>
           <a:lstStyle/>
           <a:p>
-            <a:pPr algn="l"/>
             <a:r>
-              <a:rPr sz="1400" b="0">
+              <a:rPr sz="1500" b="1">
                 <a:solidFill>
-                  <a:srgbClr val="1B2430"/>
+                  <a:srgbClr val="1F3A5F"/>
                 </a:solidFill>
                 <a:latin typeface="Calibri"/>
               </a:rPr>
-              <a:t>Kneusel [2] amaliy nuqtai nazardan SI injiniringini «modelni ishlaydigan mahsulotga aylantirish san'ati» deb ta'riflaydi va muhandis javob berishi kerak bo'lgan savollarni sanaydi: inferens…</a:t>
+              <a:t>Kneusel [2] amaliy nuqtai nazardan SI injiniringini «modelni ishlaydigan mahsulotga aylantirish san'ati» deb ta'riflaydi va muhandis javob berishi kerak bo'lgan savollarni sanaydi: inferens qayerda bajariladi (bulut, server, qurilma)?</a:t>
+            </a:r>
+          </a:p>
+          <a:p>
+            <a:pPr>
+              <a:spcBef>
+                <a:spcPts val="400"/>
+              </a:spcBef>
+            </a:pPr>
+            <a:r>
+              <a:rPr sz="1400">
+                <a:solidFill>
+                  <a:srgbClr val="334055"/>
+                </a:solidFill>
+                <a:latin typeface="Calibri"/>
+              </a:rPr>
+              <a:t>Qanday kechikish qabul qilinadi? Xato narxi qancha? Model qanchalik tez eskiradi? Ushbu savollarning har biri bevosita kompyuter tizimi arxitekturasiga ta'sir qiladi.</a:t>
             </a:r>
           </a:p>
         </p:txBody>
@@ -23086,12 +23857,12 @@
         </p:nvSpPr>
         <p:spPr>
           <a:xfrm>
-            <a:off x="550000" y="5102500"/>
-            <a:ext cx="11100000" cy="1147500"/>
+            <a:off x="550000" y="5120000"/>
+            <a:ext cx="11100000" cy="1180000"/>
           </a:xfrm>
           <a:prstGeom prst="roundRect">
             <a:avLst>
-              <a:gd name="adj" fmla="val 18000"/>
+              <a:gd name="adj" fmla="val 8000"/>
             </a:avLst>
           </a:prstGeom>
           <a:solidFill>
@@ -23132,8 +23903,8 @@
         </p:nvSpPr>
         <p:spPr>
           <a:xfrm>
-            <a:off x="550000" y="5102500"/>
-            <a:ext cx="70000" cy="1147500"/>
+            <a:off x="550000" y="5120000"/>
+            <a:ext cx="70000" cy="1180000"/>
           </a:xfrm>
           <a:prstGeom prst="rect">
             <a:avLst/>
@@ -23176,8 +23947,8 @@
         </p:nvSpPr>
         <p:spPr>
           <a:xfrm>
-            <a:off x="800000" y="5446250"/>
-            <a:ext cx="460000" cy="460000"/>
+            <a:off x="780000" y="5500000"/>
+            <a:ext cx="420000" cy="420000"/>
           </a:xfrm>
           <a:prstGeom prst="ellipse">
             <a:avLst/>
@@ -23210,7 +23981,7 @@
           <a:p>
             <a:pPr algn="ctr"/>
             <a:r>
-              <a:rPr sz="1600" b="1">
+              <a:rPr sz="1400" b="1">
                 <a:solidFill>
                   <a:srgbClr val="FFFFFF"/>
                 </a:solidFill>
@@ -23229,8 +24000,8 @@
         </p:nvSpPr>
         <p:spPr>
           <a:xfrm>
-            <a:off x="1450000" y="5102500"/>
-            <a:ext cx="10050000" cy="1147500"/>
+            <a:off x="1380000" y="5160000"/>
+            <a:ext cx="10150000" cy="1100000"/>
           </a:xfrm>
           <a:prstGeom prst="rect">
             <a:avLst/>
@@ -23238,12 +24009,11 @@
           <a:noFill/>
         </p:spPr>
         <p:txBody>
-          <a:bodyPr wrap="square" anchor="ctr" lIns="50800" rIns="50800">
+          <a:bodyPr wrap="square" anchor="ctr">
             <a:spAutoFit/>
           </a:bodyPr>
           <a:lstStyle/>
           <a:p>
-            <a:pPr algn="l"/>
             <a:r>
               <a:rPr sz="1400" b="0">
                 <a:solidFill>
@@ -26066,12 +26836,12 @@
         </p:nvSpPr>
         <p:spPr>
           <a:xfrm>
-            <a:off x="550000" y="1620000"/>
-            <a:ext cx="11100000" cy="1250000"/>
+            <a:off x="550000" y="1761824"/>
+            <a:ext cx="11100000" cy="1268784"/>
           </a:xfrm>
           <a:prstGeom prst="roundRect">
             <a:avLst>
-              <a:gd name="adj" fmla="val 18000"/>
+              <a:gd name="adj" fmla="val 8000"/>
             </a:avLst>
           </a:prstGeom>
           <a:solidFill>
@@ -26112,8 +26882,8 @@
         </p:nvSpPr>
         <p:spPr>
           <a:xfrm>
-            <a:off x="550000" y="1620000"/>
-            <a:ext cx="70000" cy="1250000"/>
+            <a:off x="550000" y="1761824"/>
+            <a:ext cx="70000" cy="1268784"/>
           </a:xfrm>
           <a:prstGeom prst="rect">
             <a:avLst/>
@@ -26156,8 +26926,8 @@
         </p:nvSpPr>
         <p:spPr>
           <a:xfrm>
-            <a:off x="800000" y="2015000"/>
-            <a:ext cx="460000" cy="460000"/>
+            <a:off x="780000" y="2186216"/>
+            <a:ext cx="420000" cy="420000"/>
           </a:xfrm>
           <a:prstGeom prst="ellipse">
             <a:avLst/>
@@ -26190,7 +26960,7 @@
           <a:p>
             <a:pPr algn="ctr"/>
             <a:r>
-              <a:rPr sz="1600" b="1">
+              <a:rPr sz="1400" b="1">
                 <a:solidFill>
                   <a:srgbClr val="FFFFFF"/>
                 </a:solidFill>
@@ -26209,8 +26979,8 @@
         </p:nvSpPr>
         <p:spPr>
           <a:xfrm>
-            <a:off x="1450000" y="1620000"/>
-            <a:ext cx="10050000" cy="1250000"/>
+            <a:off x="1380000" y="1801824"/>
+            <a:ext cx="10150000" cy="1188784"/>
           </a:xfrm>
           <a:prstGeom prst="rect">
             <a:avLst/>
@@ -26218,20 +26988,35 @@
           <a:noFill/>
         </p:spPr>
         <p:txBody>
-          <a:bodyPr wrap="square" anchor="ctr" lIns="50800" rIns="50800">
+          <a:bodyPr wrap="square" anchor="ctr">
             <a:spAutoFit/>
           </a:bodyPr>
           <a:lstStyle/>
           <a:p>
-            <a:pPr algn="l"/>
             <a:r>
-              <a:rPr sz="1600" b="0">
+              <a:rPr sz="1500" b="1">
                 <a:solidFill>
-                  <a:srgbClr val="1B2430"/>
+                  <a:srgbClr val="1F3A5F"/>
                 </a:solidFill>
                 <a:latin typeface="Calibri"/>
               </a:rPr>
-              <a:t>Hisoblash platformasi deganda biz SI yukini bajaruvchi apparat va uning ustidagi tizimli dasturiy ta'minot (drayver, kutubxona, ish vaqti muhiti) majmuasini tushunamiz. Platformalarni to'rt sinfga ajratish qulay: shaxsiy ish stansiyalari, ma'lumotlar markazi…</a:t>
+              <a:t>Hisoblash platformasi deganda biz SI yukini bajaruvchi apparat va uning ustidagi tizimli dasturiy ta'minot (drayver, kutubxona, ish vaqti muhiti) majmuasini tushunamiz.</a:t>
+            </a:r>
+          </a:p>
+          <a:p>
+            <a:pPr>
+              <a:spcBef>
+                <a:spcPts val="400"/>
+              </a:spcBef>
+            </a:pPr>
+            <a:r>
+              <a:rPr sz="1400">
+                <a:solidFill>
+                  <a:srgbClr val="334055"/>
+                </a:solidFill>
+                <a:latin typeface="Calibri"/>
+              </a:rPr>
+              <a:t>Platformalarni to'rt sinfga ajratish qulay: shaxsiy ish stansiyalari, ma'lumotlar markazi serverlari, bulut xizmatlari va chekka (edge) qurilmalar.</a:t>
             </a:r>
           </a:p>
         </p:txBody>
@@ -26244,12 +27029,12 @@
         </p:nvSpPr>
         <p:spPr>
           <a:xfrm>
-            <a:off x="550000" y="2990000"/>
-            <a:ext cx="11100000" cy="1250000"/>
+            <a:off x="550000" y="3140608"/>
+            <a:ext cx="11100000" cy="1268784"/>
           </a:xfrm>
           <a:prstGeom prst="roundRect">
             <a:avLst>
-              <a:gd name="adj" fmla="val 18000"/>
+              <a:gd name="adj" fmla="val 8000"/>
             </a:avLst>
           </a:prstGeom>
           <a:solidFill>
@@ -26290,8 +27075,8 @@
         </p:nvSpPr>
         <p:spPr>
           <a:xfrm>
-            <a:off x="550000" y="2990000"/>
-            <a:ext cx="70000" cy="1250000"/>
+            <a:off x="550000" y="3140608"/>
+            <a:ext cx="70000" cy="1268784"/>
           </a:xfrm>
           <a:prstGeom prst="rect">
             <a:avLst/>
@@ -26334,8 +27119,8 @@
         </p:nvSpPr>
         <p:spPr>
           <a:xfrm>
-            <a:off x="800000" y="3385000"/>
-            <a:ext cx="460000" cy="460000"/>
+            <a:off x="780000" y="3565000"/>
+            <a:ext cx="420000" cy="420000"/>
           </a:xfrm>
           <a:prstGeom prst="ellipse">
             <a:avLst/>
@@ -26368,7 +27153,7 @@
           <a:p>
             <a:pPr algn="ctr"/>
             <a:r>
-              <a:rPr sz="1600" b="1">
+              <a:rPr sz="1400" b="1">
                 <a:solidFill>
                   <a:srgbClr val="FFFFFF"/>
                 </a:solidFill>
@@ -26387,8 +27172,8 @@
         </p:nvSpPr>
         <p:spPr>
           <a:xfrm>
-            <a:off x="1450000" y="2990000"/>
-            <a:ext cx="10050000" cy="1250000"/>
+            <a:off x="1380000" y="3180608"/>
+            <a:ext cx="10150000" cy="1188784"/>
           </a:xfrm>
           <a:prstGeom prst="rect">
             <a:avLst/>
@@ -26396,20 +27181,35 @@
           <a:noFill/>
         </p:spPr>
         <p:txBody>
-          <a:bodyPr wrap="square" anchor="ctr" lIns="50800" rIns="50800">
+          <a:bodyPr wrap="square" anchor="ctr">
             <a:spAutoFit/>
           </a:bodyPr>
           <a:lstStyle/>
           <a:p>
-            <a:pPr algn="l"/>
             <a:r>
-              <a:rPr sz="1600" b="0">
+              <a:rPr sz="1500" b="1">
                 <a:solidFill>
-                  <a:srgbClr val="1B2430"/>
+                  <a:srgbClr val="1F3A5F"/>
                 </a:solidFill>
                 <a:latin typeface="Calibri"/>
               </a:rPr>
-              <a:t>Jadvaldan uch muhim xulosa kelib chiqadi. Birinchidan, platformalar orasidagi farq olti tartibni (10⁶) tashkil etadi — mikrokontrollerdan H100 gacha.</a:t>
+              <a:t>Jadvaldan uch muhim xulosa kelib chiqadi.</a:t>
+            </a:r>
+          </a:p>
+          <a:p>
+            <a:pPr>
+              <a:spcBef>
+                <a:spcPts val="400"/>
+              </a:spcBef>
+            </a:pPr>
+            <a:r>
+              <a:rPr sz="1400">
+                <a:solidFill>
+                  <a:srgbClr val="334055"/>
+                </a:solidFill>
+                <a:latin typeface="Calibri"/>
+              </a:rPr>
+              <a:t>Birinchidan, platformalar orasidagi farq olti tartibni (10⁶) tashkil etadi — mikrokontrollerdan H100 gacha. Demak «model ishlaydimi?» savoli ma'nosiz; «qaysi platformada, qanday kechikish va energiya bilan ishlaydi?» deb so'rash kerak.</a:t>
             </a:r>
           </a:p>
         </p:txBody>
@@ -26422,12 +27222,12 @@
         </p:nvSpPr>
         <p:spPr>
           <a:xfrm>
-            <a:off x="550000" y="4360000"/>
-            <a:ext cx="11100000" cy="1250000"/>
+            <a:off x="550000" y="4519392"/>
+            <a:ext cx="11100000" cy="1268784"/>
           </a:xfrm>
           <a:prstGeom prst="roundRect">
             <a:avLst>
-              <a:gd name="adj" fmla="val 18000"/>
+              <a:gd name="adj" fmla="val 8000"/>
             </a:avLst>
           </a:prstGeom>
           <a:solidFill>
@@ -26468,8 +27268,8 @@
         </p:nvSpPr>
         <p:spPr>
           <a:xfrm>
-            <a:off x="550000" y="4360000"/>
-            <a:ext cx="70000" cy="1250000"/>
+            <a:off x="550000" y="4519392"/>
+            <a:ext cx="70000" cy="1268784"/>
           </a:xfrm>
           <a:prstGeom prst="rect">
             <a:avLst/>
@@ -26512,8 +27312,8 @@
         </p:nvSpPr>
         <p:spPr>
           <a:xfrm>
-            <a:off x="800000" y="4755000"/>
-            <a:ext cx="460000" cy="460000"/>
+            <a:off x="780000" y="4943784"/>
+            <a:ext cx="420000" cy="420000"/>
           </a:xfrm>
           <a:prstGeom prst="ellipse">
             <a:avLst/>
@@ -26546,7 +27346,7 @@
           <a:p>
             <a:pPr algn="ctr"/>
             <a:r>
-              <a:rPr sz="1600" b="1">
+              <a:rPr sz="1400" b="1">
                 <a:solidFill>
                   <a:srgbClr val="FFFFFF"/>
                 </a:solidFill>
@@ -26565,8 +27365,8 @@
         </p:nvSpPr>
         <p:spPr>
           <a:xfrm>
-            <a:off x="1450000" y="4360000"/>
-            <a:ext cx="10050000" cy="1250000"/>
+            <a:off x="1380000" y="4559392"/>
+            <a:ext cx="10150000" cy="1188784"/>
           </a:xfrm>
           <a:prstGeom prst="rect">
             <a:avLst/>
@@ -26574,20 +27374,35 @@
           <a:noFill/>
         </p:spPr>
         <p:txBody>
-          <a:bodyPr wrap="square" anchor="ctr" lIns="50800" rIns="50800">
+          <a:bodyPr wrap="square" anchor="ctr">
             <a:spAutoFit/>
           </a:bodyPr>
           <a:lstStyle/>
           <a:p>
-            <a:pPr algn="l"/>
             <a:r>
-              <a:rPr sz="1600" b="0">
+              <a:rPr sz="1500" b="1">
                 <a:solidFill>
-                  <a:srgbClr val="1B2430"/>
+                  <a:srgbClr val="1F3A5F"/>
                 </a:solidFill>
                 <a:latin typeface="Calibri"/>
               </a:rPr>
-              <a:t>Platforma tanlashda hisoblash quvvatining birligiga e'tibor berish zarur. TOPS (tera operations per second) odatda INT8 butun sonli amallar uchun, TFLOPS esa suzuvchi nuqtali (FP32, FP16, BF16, FP8) amallar uchun beriladi.</a:t>
+              <a:t>Platforma tanlashda hisoblash quvvatining birligiga e'tibor berish zarur.</a:t>
+            </a:r>
+          </a:p>
+          <a:p>
+            <a:pPr>
+              <a:spcBef>
+                <a:spcPts val="400"/>
+              </a:spcBef>
+            </a:pPr>
+            <a:r>
+              <a:rPr sz="1400">
+                <a:solidFill>
+                  <a:srgbClr val="334055"/>
+                </a:solidFill>
+                <a:latin typeface="Calibri"/>
+              </a:rPr>
+              <a:t>TOPS (tera operations per second) odatda INT8 butun sonli amallar uchun, TFLOPS esa suzuvchi nuqtali (FP32, FP16, BF16, FP8) amallar uchun beriladi. Bitta ko'paytirish-qo'shish (multiply-accumulate, MAC) amali ikki operatsiya sifatida hisoblanadi.</a:t>
             </a:r>
           </a:p>
         </p:txBody>

</xml_diff>